<commit_message>
docs/slides: save final PowerPoint revisions
</commit_message>
<xml_diff>
--- a/poc/refresh/0827_slide_codex_v4.pptx
+++ b/poc/refresh/0827_slide_codex_v4.pptx
@@ -17,7 +17,7 @@
     <p:sldId id="261" r:id="rId8"/>
     <p:sldId id="262" r:id="rId9"/>
     <p:sldId id="263" r:id="rId10"/>
-    <p:sldId id="264" r:id="rId11"/>
+    <p:sldId id="276" r:id="rId11"/>
     <p:sldId id="265" r:id="rId12"/>
     <p:sldId id="266" r:id="rId13"/>
     <p:sldId id="267" r:id="rId14"/>
@@ -385,7 +385,13 @@
   <p:cSld>
     <p:spTree>
       <p:nvGrpSpPr>
-        <p:cNvPr id="1" name=""/>
+        <p:cNvPr id="1" name="">
+          <a:extLst>
+            <a:ext uri="{FF2B5EF4-FFF2-40B4-BE49-F238E27FC236}">
+              <a16:creationId xmlns:a16="http://schemas.microsoft.com/office/drawing/2014/main" id="{4D5624BA-66AE-8FE7-CEEE-AF777A0F0DB5}"/>
+            </a:ext>
+          </a:extLst>
+        </p:cNvPr>
         <p:cNvGrpSpPr/>
         <p:nvPr/>
       </p:nvGrpSpPr>
@@ -399,7 +405,13 @@
       </p:grpSpPr>
       <p:sp>
         <p:nvSpPr>
-          <p:cNvPr id="2" name="Slide Image Placeholder 1"/>
+          <p:cNvPr id="2" name="Slide Image Placeholder 1">
+            <a:extLst>
+              <a:ext uri="{FF2B5EF4-FFF2-40B4-BE49-F238E27FC236}">
+                <a16:creationId xmlns:a16="http://schemas.microsoft.com/office/drawing/2014/main" id="{0FDC0569-F530-999E-44E4-1140A8B702B1}"/>
+              </a:ext>
+            </a:extLst>
+          </p:cNvPr>
           <p:cNvSpPr>
             <a:spLocks noGrp="1" noRot="1" noChangeAspect="1"/>
           </p:cNvSpPr>
@@ -411,7 +423,13 @@
       </p:sp>
       <p:sp>
         <p:nvSpPr>
-          <p:cNvPr id="3" name="Notes Placeholder 2"/>
+          <p:cNvPr id="3" name="Notes Placeholder 2">
+            <a:extLst>
+              <a:ext uri="{FF2B5EF4-FFF2-40B4-BE49-F238E27FC236}">
+                <a16:creationId xmlns:a16="http://schemas.microsoft.com/office/drawing/2014/main" id="{83791363-86D0-13C9-4808-54744DAC1760}"/>
+              </a:ext>
+            </a:extLst>
+          </p:cNvPr>
           <p:cNvSpPr>
             <a:spLocks noGrp="1"/>
           </p:cNvSpPr>
@@ -424,13 +442,39 @@
           <a:bodyPr/>
           <a:lstStyle/>
           <a:p>
+            <a:pPr marL="171450" indent="-171450">
+              <a:buFontTx/>
+              <a:buChar char="-"/>
+            </a:pPr>
+            <a:r>
+              <a:t>說明各階段驗收目標 &amp; 非 DBA 外協作單位的 Requement</a:t>
+            </a:r>
+          </a:p>
+          <a:p>
+            <a:pPr marL="171450" indent="-171450">
+              <a:buFontTx/>
+              <a:buChar char="-"/>
+            </a:pPr>
             <a:endParaRPr/>
           </a:p>
-        </p:txBody>
-      </p:sp>
-      <p:sp>
-        <p:nvSpPr>
-          <p:cNvPr id="4" name="Slide Number Placeholder 3"/>
+          <a:p>
+            <a:pPr marL="171450" indent="-171450">
+              <a:buFontTx/>
+              <a:buChar char="-"/>
+            </a:pPr>
+            <a:endParaRPr/>
+          </a:p>
+        </p:txBody>
+      </p:sp>
+      <p:sp>
+        <p:nvSpPr>
+          <p:cNvPr id="4" name="Slide Number Placeholder 3">
+            <a:extLst>
+              <a:ext uri="{FF2B5EF4-FFF2-40B4-BE49-F238E27FC236}">
+                <a16:creationId xmlns:a16="http://schemas.microsoft.com/office/drawing/2014/main" id="{33431AC4-B15E-DFC3-210A-617303B4813A}"/>
+              </a:ext>
+            </a:extLst>
+          </p:cNvPr>
           <p:cNvSpPr>
             <a:spLocks noGrp="1"/>
           </p:cNvSpPr>
@@ -448,6 +492,11 @@
         </p:txBody>
       </p:sp>
     </p:spTree>
+    <p:extLst>
+      <p:ext uri="{BB962C8B-B14F-4D97-AF65-F5344CB8AC3E}">
+        <p14:creationId xmlns:p14="http://schemas.microsoft.com/office/powerpoint/2010/main" val="2729967375"/>
+      </p:ext>
+    </p:extLst>
   </p:cSld>
   <p:clrMapOvr>
     <a:masterClrMapping/>
@@ -1578,14 +1627,7 @@
           <a:bodyPr/>
           <a:lstStyle/>
           <a:p>
-            <a:r>
-              <a:t>增加其他類別資料庫數據數據</a:t>
-            </a:r>
-          </a:p>
-          <a:p>
-            <a:r>
-              <a:t>增加卡片說明 應用層級  YBDB &amp; CRDB 應用考量</a:t>
-            </a:r>
+            <a:endParaRPr dirty="0"/>
           </a:p>
         </p:txBody>
       </p:sp>
@@ -1814,23 +1856,7 @@
               <a:buFontTx/>
               <a:buChar char="-"/>
             </a:pPr>
-            <a:r>
-              <a:t>說明各階段驗收目標 &amp; 非 DBA 外協作單位的 Requement</a:t>
-            </a:r>
-          </a:p>
-          <a:p>
-            <a:pPr marL="171450" indent="-171450">
-              <a:buFontTx/>
-              <a:buChar char="-"/>
-            </a:pPr>
-            <a:endParaRPr/>
-          </a:p>
-          <a:p>
-            <a:pPr marL="171450" indent="-171450">
-              <a:buFontTx/>
-              <a:buChar char="-"/>
-            </a:pPr>
-            <a:endParaRPr/>
+            <a:endParaRPr dirty="0"/>
           </a:p>
         </p:txBody>
       </p:sp>
@@ -2504,7 +2530,7 @@
               </a:defRPr>
             </a:pPr>
             <a:r>
-              <a:rPr sz="1725" b="1">
+              <a:rPr sz="1725" b="1" dirty="0" err="1">
                 <a:solidFill>
                   <a:srgbClr val="2563EB"/>
                 </a:solidFill>
@@ -2512,8 +2538,115 @@
                 <a:ea typeface="PingFang TC"/>
                 <a:cs typeface="PingFang TC"/>
               </a:rPr>
-              <a:t>從多寫目標，收斂為可交付的 A/S → A/A (RO) 路線</a:t>
-            </a:r>
+              <a:t>從</a:t>
+            </a:r>
+            <a:r>
+              <a:rPr lang="en-US" sz="1725" b="1" dirty="0" err="1">
+                <a:solidFill>
+                  <a:srgbClr val="2563EB"/>
+                </a:solidFill>
+                <a:latin typeface="PingFang TC"/>
+                <a:ea typeface="PingFang TC"/>
+                <a:cs typeface="PingFang TC"/>
+              </a:rPr>
+              <a:t>雙活機房</a:t>
+            </a:r>
+            <a:r>
+              <a:rPr sz="1725" b="1" dirty="0" err="1">
+                <a:solidFill>
+                  <a:srgbClr val="2563EB"/>
+                </a:solidFill>
+                <a:latin typeface="PingFang TC"/>
+                <a:ea typeface="PingFang TC"/>
+                <a:cs typeface="PingFang TC"/>
+              </a:rPr>
+              <a:t>多寫目標，收斂為</a:t>
+            </a:r>
+            <a:r>
+              <a:rPr lang="en-US" sz="1725" b="1" dirty="0" err="1">
+                <a:solidFill>
+                  <a:srgbClr val="2563EB"/>
+                </a:solidFill>
+                <a:latin typeface="PingFang TC"/>
+                <a:ea typeface="PingFang TC"/>
+                <a:cs typeface="PingFang TC"/>
+              </a:rPr>
+              <a:t>使用</a:t>
+            </a:r>
+            <a:r>
+              <a:rPr lang="en-US" sz="1725" b="1" dirty="0">
+                <a:solidFill>
+                  <a:srgbClr val="2563EB"/>
+                </a:solidFill>
+                <a:latin typeface="PingFang TC"/>
+                <a:ea typeface="PingFang TC"/>
+                <a:cs typeface="PingFang TC"/>
+              </a:rPr>
+              <a:t> </a:t>
+            </a:r>
+            <a:r>
+              <a:rPr lang="en-US" sz="1725" b="1" dirty="0" err="1">
+                <a:solidFill>
+                  <a:srgbClr val="2563EB"/>
+                </a:solidFill>
+                <a:latin typeface="PingFang TC"/>
+                <a:ea typeface="PingFang TC"/>
+                <a:cs typeface="PingFang TC"/>
+              </a:rPr>
+              <a:t>TiDB</a:t>
+            </a:r>
+            <a:r>
+              <a:rPr lang="en-US" sz="1725" b="1" dirty="0">
+                <a:solidFill>
+                  <a:srgbClr val="2563EB"/>
+                </a:solidFill>
+                <a:latin typeface="PingFang TC"/>
+                <a:ea typeface="PingFang TC"/>
+                <a:cs typeface="PingFang TC"/>
+              </a:rPr>
+              <a:t> </a:t>
+            </a:r>
+            <a:r>
+              <a:rPr sz="1725" b="1" dirty="0" err="1">
+                <a:solidFill>
+                  <a:srgbClr val="2563EB"/>
+                </a:solidFill>
+                <a:latin typeface="PingFang TC"/>
+                <a:ea typeface="PingFang TC"/>
+                <a:cs typeface="PingFang TC"/>
+              </a:rPr>
+              <a:t>的</a:t>
+            </a:r>
+            <a:r>
+              <a:rPr sz="1725" b="1" dirty="0">
+                <a:solidFill>
+                  <a:srgbClr val="2563EB"/>
+                </a:solidFill>
+                <a:latin typeface="PingFang TC"/>
+                <a:ea typeface="PingFang TC"/>
+                <a:cs typeface="PingFang TC"/>
+              </a:rPr>
+              <a:t> A/S → A/A (RO) </a:t>
+            </a:r>
+            <a:r>
+              <a:rPr sz="1725" b="1" dirty="0" err="1">
+                <a:solidFill>
+                  <a:srgbClr val="2563EB"/>
+                </a:solidFill>
+                <a:latin typeface="PingFang TC"/>
+                <a:ea typeface="PingFang TC"/>
+                <a:cs typeface="PingFang TC"/>
+              </a:rPr>
+              <a:t>路線</a:t>
+            </a:r>
+            <a:endParaRPr sz="1725" b="1" dirty="0">
+              <a:solidFill>
+                <a:srgbClr val="2563EB"/>
+              </a:solidFill>
+              <a:latin typeface="PingFang TC"/>
+              <a:ea typeface="PingFang TC"/>
+              <a:cs typeface="PingFang TC"/>
+            </a:endParaRPr>
           </a:p>
         </p:txBody>
       </p:sp>
@@ -2533,17 +2666,15 @@
 <file path=ppt/slides/slide10.xml><?xml version="1.0" encoding="utf-8"?>
 <p:sld xmlns:a="http://schemas.openxmlformats.org/drawingml/2006/main" xmlns:r="http://schemas.openxmlformats.org/officeDocument/2006/relationships" xmlns:p="http://schemas.openxmlformats.org/presentationml/2006/main">
   <p:cSld>
-    <p:bg>
-      <p:bgPr>
-        <a:solidFill>
-          <a:srgbClr val="FFFFFF"/>
-        </a:solidFill>
-        <a:effectLst/>
-      </p:bgPr>
-    </p:bg>
     <p:spTree>
       <p:nvGrpSpPr>
-        <p:cNvPr id="1" name=""/>
+        <p:cNvPr id="1" name="">
+          <a:extLst>
+            <a:ext uri="{FF2B5EF4-FFF2-40B4-BE49-F238E27FC236}">
+              <a16:creationId xmlns:a16="http://schemas.microsoft.com/office/drawing/2014/main" id="{3B442B2F-083F-E3DF-0EB0-7EEB0CC16227}"/>
+            </a:ext>
+          </a:extLst>
+        </p:cNvPr>
         <p:cNvGrpSpPr/>
         <p:nvPr/>
       </p:nvGrpSpPr>
@@ -2560,7 +2691,7 @@
           <p:cNvPr id="3" name="矩形 2">
             <a:extLst>
               <a:ext uri="{FF2B5EF4-FFF2-40B4-BE49-F238E27FC236}">
-                <a16:creationId xmlns:a16="http://schemas.microsoft.com/office/drawing/2014/main" id="{D4A2FC06-450E-4253-AB3F-3B16716880B3}"/>
+                <a16:creationId xmlns:a16="http://schemas.microsoft.com/office/drawing/2014/main" id="{B28F08A1-1851-8D17-45BC-3189E8DA9068}"/>
               </a:ext>
             </a:extLst>
           </p:cNvPr>
@@ -2609,7 +2740,7 @@
                 <a:ea typeface="PingFang TC"/>
                 <a:cs typeface="PingFang TC"/>
               </a:rPr>
-              <a:t>OPERATING MODEL</a:t>
+              <a:t>TARGET ROUTE</a:t>
             </a:r>
           </a:p>
         </p:txBody>
@@ -2619,7 +2750,7 @@
           <p:cNvPr id="2" name="矩形 1">
             <a:extLst>
               <a:ext uri="{FF2B5EF4-FFF2-40B4-BE49-F238E27FC236}">
-                <a16:creationId xmlns:a16="http://schemas.microsoft.com/office/drawing/2014/main" id="{8799B607-DDCF-4212-89EB-E2381385F4A6}"/>
+                <a16:creationId xmlns:a16="http://schemas.microsoft.com/office/drawing/2014/main" id="{EEF4A94D-80FC-A36F-1C7D-3B8E79926FEB}"/>
               </a:ext>
             </a:extLst>
           </p:cNvPr>
@@ -2648,8 +2779,7 @@
           </a:bodyPr>
           <a:lstStyle/>
           <a:p>
-            <a:pPr algn="l">
-              <a:buNone/>
+            <a:pPr>
               <a:defRPr sz="3000" b="1">
                 <a:solidFill>
                   <a:srgbClr val="111827"/>
@@ -2660,7 +2790,7 @@
               </a:defRPr>
             </a:pPr>
             <a:r>
-              <a:rPr sz="3000" b="1">
+              <a:rPr lang="zh-TW" altLang="en-US" sz="3000" b="1" dirty="0">
                 <a:solidFill>
                   <a:srgbClr val="111827"/>
                 </a:solidFill>
@@ -2668,334 +2798,9 @@
                 <a:ea typeface="PingFang TC"/>
                 <a:cs typeface="PingFang TC"/>
               </a:rPr>
-              <a:t>技術主線、產品服務化、維運後勤可以並行</a:t>
-            </a:r>
-          </a:p>
-        </p:txBody>
-      </p:sp>
-      <p:cxnSp>
-        <p:nvCxnSpPr>
-          <p:cNvPr id="30" name="直線箭頭接點 20"/>
-          <p:cNvCxnSpPr/>
-          <p:nvPr/>
-        </p:nvCxnSpPr>
-        <p:spPr>
-          <a:xfrm>
-            <a:off x="495300" y="1323975"/>
-            <a:ext cx="11201400" cy="0"/>
-          </a:xfrm>
-          <a:prstGeom prst="straightConnector1">
-            <a:avLst/>
-          </a:prstGeom>
-          <a:ln w="9525">
-            <a:solidFill>
-              <a:srgbClr val="D0D5DD"/>
-            </a:solidFill>
-            <a:prstDash val="solid"/>
-          </a:ln>
-        </p:spPr>
-      </p:cxnSp>
-      <p:sp>
-        <p:nvSpPr>
-          <p:cNvPr id="4" name="矩形 3">
-            <a:extLst>
-              <a:ext uri="{FF2B5EF4-FFF2-40B4-BE49-F238E27FC236}">
-                <a16:creationId xmlns:a16="http://schemas.microsoft.com/office/drawing/2014/main" id="{95A3F048-88A2-45A9-8057-B871F1DF4665}"/>
-              </a:ext>
-            </a:extLst>
-          </p:cNvPr>
-          <p:cNvSpPr>
-            <a:spLocks noGrp="1"/>
-          </p:cNvSpPr>
-          <p:nvPr/>
-        </p:nvSpPr>
-        <p:spPr>
-          <a:xfrm>
-            <a:off x="11182350" y="6391275"/>
-            <a:ext cx="514350" cy="190500"/>
-          </a:xfrm>
-          <a:prstGeom prst="rect">
-            <a:avLst/>
-          </a:prstGeom>
-          <a:noFill/>
-          <a:ln w="0">
-            <a:noFill/>
-            <a:prstDash val="solid"/>
-          </a:ln>
-        </p:spPr>
-        <p:txBody>
-          <a:bodyPr wrap="square" lIns="0" tIns="0" rIns="0" bIns="0" anchor="t">
-            <a:normAutofit/>
-          </a:bodyPr>
-          <a:lstStyle/>
-          <a:p>
-            <a:pPr algn="r">
-              <a:buNone/>
-              <a:defRPr sz="900" b="0">
-                <a:solidFill>
-                  <a:srgbClr val="667085"/>
-                </a:solidFill>
-                <a:latin typeface="PingFang TC"/>
-                <a:ea typeface="PingFang TC"/>
-                <a:cs typeface="PingFang TC"/>
-              </a:defRPr>
-            </a:pPr>
-            <a:r>
-              <a:rPr sz="900" b="0">
-                <a:solidFill>
-                  <a:srgbClr val="667085"/>
-                </a:solidFill>
-                <a:latin typeface="PingFang TC"/>
-                <a:ea typeface="PingFang TC"/>
-                <a:cs typeface="PingFang TC"/>
-              </a:rPr>
-              <a:t>12</a:t>
-            </a:r>
-          </a:p>
-        </p:txBody>
-      </p:sp>
-      <p:sp>
-        <p:nvSpPr>
-          <p:cNvPr id="5" name="矩形 4">
-            <a:extLst>
-              <a:ext uri="{FF2B5EF4-FFF2-40B4-BE49-F238E27FC236}">
-                <a16:creationId xmlns:a16="http://schemas.microsoft.com/office/drawing/2014/main" id="{A67A8A4B-84C4-48E4-AA88-C3378F0139E4}"/>
-              </a:ext>
-            </a:extLst>
-          </p:cNvPr>
-          <p:cNvSpPr>
-            <a:spLocks noGrp="1"/>
-          </p:cNvSpPr>
-          <p:nvPr/>
-        </p:nvSpPr>
-        <p:spPr>
-          <a:xfrm>
-            <a:off x="495300" y="1657350"/>
-            <a:ext cx="3333750" cy="3714750"/>
-          </a:xfrm>
-          <a:prstGeom prst="rect">
-            <a:avLst/>
-          </a:prstGeom>
-          <a:solidFill>
-            <a:srgbClr val="E9F2FF"/>
-          </a:solidFill>
-          <a:ln w="0">
-            <a:noFill/>
-            <a:prstDash val="solid"/>
-          </a:ln>
-        </p:spPr>
-        <p:txBody>
-          <a:bodyPr/>
-          <a:lstStyle/>
-          <a:p>
-            <a:endParaRPr/>
-          </a:p>
-        </p:txBody>
-      </p:sp>
-      <p:sp>
-        <p:nvSpPr>
-          <p:cNvPr id="6" name="矩形 5">
-            <a:extLst>
-              <a:ext uri="{FF2B5EF4-FFF2-40B4-BE49-F238E27FC236}">
-                <a16:creationId xmlns:a16="http://schemas.microsoft.com/office/drawing/2014/main" id="{43941BEF-5C97-4A25-A327-361372EF2EEA}"/>
-              </a:ext>
-            </a:extLst>
-          </p:cNvPr>
-          <p:cNvSpPr>
-            <a:spLocks noGrp="1"/>
-          </p:cNvSpPr>
-          <p:nvPr/>
-        </p:nvSpPr>
-        <p:spPr>
-          <a:xfrm>
-            <a:off x="495300" y="1657350"/>
-            <a:ext cx="66675" cy="3714750"/>
-          </a:xfrm>
-          <a:prstGeom prst="rect">
-            <a:avLst/>
-          </a:prstGeom>
-          <a:solidFill>
-            <a:srgbClr val="2563EB"/>
-          </a:solidFill>
-          <a:ln w="0">
-            <a:noFill/>
-            <a:prstDash val="solid"/>
-          </a:ln>
-        </p:spPr>
-        <p:txBody>
-          <a:bodyPr/>
-          <a:lstStyle/>
-          <a:p>
-            <a:endParaRPr/>
-          </a:p>
-        </p:txBody>
-      </p:sp>
-      <p:sp>
-        <p:nvSpPr>
-          <p:cNvPr id="7" name="矩形 6">
-            <a:extLst>
-              <a:ext uri="{FF2B5EF4-FFF2-40B4-BE49-F238E27FC236}">
-                <a16:creationId xmlns:a16="http://schemas.microsoft.com/office/drawing/2014/main" id="{3810BCDF-0605-4CCE-84E8-9916B9BA0A88}"/>
-              </a:ext>
-            </a:extLst>
-          </p:cNvPr>
-          <p:cNvSpPr>
-            <a:spLocks noGrp="1"/>
-          </p:cNvSpPr>
-          <p:nvPr/>
-        </p:nvSpPr>
-        <p:spPr>
-          <a:xfrm>
-            <a:off x="723900" y="1866900"/>
-            <a:ext cx="2876550" cy="342900"/>
-          </a:xfrm>
-          <a:prstGeom prst="rect">
-            <a:avLst/>
-          </a:prstGeom>
-          <a:noFill/>
-          <a:ln w="0">
-            <a:noFill/>
-            <a:prstDash val="solid"/>
-          </a:ln>
-        </p:spPr>
-        <p:txBody>
-          <a:bodyPr wrap="square" lIns="0" tIns="0" rIns="0" bIns="0" anchor="t">
-            <a:normAutofit/>
-          </a:bodyPr>
-          <a:lstStyle/>
-          <a:p>
-            <a:pPr algn="l">
-              <a:buNone/>
-              <a:defRPr sz="1725" b="1">
-                <a:solidFill>
-                  <a:srgbClr val="111827"/>
-                </a:solidFill>
-                <a:latin typeface="PingFang TC"/>
-                <a:ea typeface="PingFang TC"/>
-                <a:cs typeface="PingFang TC"/>
-              </a:defRPr>
-            </a:pPr>
-            <a:r>
-              <a:rPr sz="1725" b="1">
-                <a:solidFill>
-                  <a:srgbClr val="111827"/>
-                </a:solidFill>
-                <a:latin typeface="PingFang TC"/>
-                <a:ea typeface="PingFang TC"/>
-                <a:cs typeface="PingFang TC"/>
-              </a:rPr>
-              <a:t>技術主線</a:t>
-            </a:r>
-          </a:p>
-        </p:txBody>
-      </p:sp>
-      <p:sp>
-        <p:nvSpPr>
-          <p:cNvPr id="8" name="矩形 7">
-            <a:extLst>
-              <a:ext uri="{FF2B5EF4-FFF2-40B4-BE49-F238E27FC236}">
-                <a16:creationId xmlns:a16="http://schemas.microsoft.com/office/drawing/2014/main" id="{DE985C52-90FC-4CF9-A834-0F9CC2C71EC5}"/>
-              </a:ext>
-            </a:extLst>
-          </p:cNvPr>
-          <p:cNvSpPr>
-            <a:spLocks noGrp="1"/>
-          </p:cNvSpPr>
-          <p:nvPr/>
-        </p:nvSpPr>
-        <p:spPr>
-          <a:xfrm>
-            <a:off x="723900" y="2305050"/>
-            <a:ext cx="2876550" cy="2895600"/>
-          </a:xfrm>
-          <a:prstGeom prst="rect">
-            <a:avLst/>
-          </a:prstGeom>
-          <a:noFill/>
-          <a:ln w="0">
-            <a:noFill/>
-            <a:prstDash val="solid"/>
-          </a:ln>
-        </p:spPr>
-        <p:txBody>
-          <a:bodyPr wrap="square" lIns="0" tIns="0" rIns="0" bIns="0" anchor="t">
-            <a:normAutofit/>
-          </a:bodyPr>
-          <a:lstStyle/>
-          <a:p>
-            <a:pPr algn="l">
-              <a:buNone/>
-              <a:defRPr sz="1575" b="0">
-                <a:solidFill>
-                  <a:srgbClr val="111827"/>
-                </a:solidFill>
-                <a:latin typeface="PingFang TC"/>
-                <a:ea typeface="PingFang TC"/>
-                <a:cs typeface="PingFang TC"/>
-              </a:defRPr>
-            </a:pPr>
-            <a:r>
-              <a:rPr sz="1575" b="0">
-                <a:solidFill>
-                  <a:srgbClr val="111827"/>
-                </a:solidFill>
-                <a:latin typeface="PingFang TC"/>
-                <a:ea typeface="PingFang TC"/>
-                <a:cs typeface="PingFang TC"/>
-              </a:rPr>
-              <a:t>S0 IDC Only</a:t>
-            </a:r>
-          </a:p>
-          <a:p>
-            <a:pPr algn="l">
-              <a:buNone/>
-              <a:defRPr sz="1575" b="0">
-                <a:solidFill>
-                  <a:srgbClr val="111827"/>
-                </a:solidFill>
-                <a:latin typeface="PingFang TC"/>
-                <a:ea typeface="PingFang TC"/>
-                <a:cs typeface="PingFang TC"/>
-              </a:defRPr>
-            </a:pPr>
-            <a:r>
-              <a:rPr sz="1575" b="0">
-                <a:solidFill>
-                  <a:srgbClr val="111827"/>
-                </a:solidFill>
-                <a:latin typeface="PingFang TC"/>
-                <a:ea typeface="PingFang TC"/>
-                <a:cs typeface="PingFang TC"/>
-              </a:rPr>
-              <a:t>→ S1 A/S</a:t>
-            </a:r>
-          </a:p>
-          <a:p>
-            <a:pPr algn="l">
-              <a:buNone/>
-              <a:defRPr sz="1575" b="0">
-                <a:solidFill>
-                  <a:srgbClr val="111827"/>
-                </a:solidFill>
-                <a:latin typeface="PingFang TC"/>
-                <a:ea typeface="PingFang TC"/>
-                <a:cs typeface="PingFang TC"/>
-              </a:defRPr>
-            </a:pPr>
-            <a:r>
-              <a:rPr sz="1575" b="0">
-                <a:solidFill>
-                  <a:srgbClr val="111827"/>
-                </a:solidFill>
-                <a:latin typeface="PingFang TC"/>
-                <a:ea typeface="PingFang TC"/>
-                <a:cs typeface="PingFang TC"/>
-              </a:rPr>
-              <a:t>→ S2 A/A-RO</a:t>
-            </a:r>
-          </a:p>
-          <a:p>
-            <a:endParaRPr sz="1575" b="0">
+              <a:t>產品期待</a:t>
+            </a:r>
+            <a:endParaRPr lang="en-US" altLang="zh-TW" sz="3000" b="1" dirty="0">
               <a:solidFill>
                 <a:srgbClr val="111827"/>
               </a:solidFill>
@@ -3004,50 +2809,172 @@
               <a:cs typeface="PingFang TC"/>
             </a:endParaRPr>
           </a:p>
+        </p:txBody>
+      </p:sp>
+      <p:cxnSp>
+        <p:nvCxnSpPr>
+          <p:cNvPr id="55" name="直線箭頭接點 33">
+            <a:extLst>
+              <a:ext uri="{FF2B5EF4-FFF2-40B4-BE49-F238E27FC236}">
+                <a16:creationId xmlns:a16="http://schemas.microsoft.com/office/drawing/2014/main" id="{9E06CEA7-8D4C-127E-F298-5E5E6C1D614F}"/>
+              </a:ext>
+            </a:extLst>
+          </p:cNvPr>
+          <p:cNvCxnSpPr/>
+          <p:nvPr/>
+        </p:nvCxnSpPr>
+        <p:spPr>
+          <a:xfrm>
+            <a:off x="495300" y="1323975"/>
+            <a:ext cx="11201400" cy="0"/>
+          </a:xfrm>
+          <a:prstGeom prst="straightConnector1">
+            <a:avLst/>
+          </a:prstGeom>
+          <a:ln w="9525">
+            <a:solidFill>
+              <a:srgbClr val="D0D5DD"/>
+            </a:solidFill>
+            <a:prstDash val="solid"/>
+          </a:ln>
+        </p:spPr>
+      </p:cxnSp>
+      <p:sp>
+        <p:nvSpPr>
+          <p:cNvPr id="4" name="矩形 3">
+            <a:extLst>
+              <a:ext uri="{FF2B5EF4-FFF2-40B4-BE49-F238E27FC236}">
+                <a16:creationId xmlns:a16="http://schemas.microsoft.com/office/drawing/2014/main" id="{D504FF88-8CE5-D4BD-9612-AC117861AB8B}"/>
+              </a:ext>
+            </a:extLst>
+          </p:cNvPr>
+          <p:cNvSpPr>
+            <a:spLocks noGrp="1"/>
+          </p:cNvSpPr>
+          <p:nvPr/>
+        </p:nvSpPr>
+        <p:spPr>
+          <a:xfrm>
+            <a:off x="11182350" y="6391275"/>
+            <a:ext cx="514350" cy="190500"/>
+          </a:xfrm>
+          <a:prstGeom prst="rect">
+            <a:avLst/>
+          </a:prstGeom>
+          <a:noFill/>
+          <a:ln w="0">
+            <a:noFill/>
+            <a:prstDash val="solid"/>
+          </a:ln>
+        </p:spPr>
+        <p:txBody>
+          <a:bodyPr wrap="square" lIns="0" tIns="0" rIns="0" bIns="0" anchor="t">
+            <a:normAutofit/>
+          </a:bodyPr>
+          <a:lstStyle/>
+          <a:p>
+            <a:pPr algn="r">
+              <a:buNone/>
+              <a:defRPr sz="900" b="0">
+                <a:solidFill>
+                  <a:srgbClr val="667085"/>
+                </a:solidFill>
+                <a:latin typeface="PingFang TC"/>
+                <a:ea typeface="PingFang TC"/>
+                <a:cs typeface="PingFang TC"/>
+              </a:defRPr>
+            </a:pPr>
+            <a:r>
+              <a:rPr sz="900" b="0">
+                <a:solidFill>
+                  <a:srgbClr val="667085"/>
+                </a:solidFill>
+                <a:latin typeface="PingFang TC"/>
+                <a:ea typeface="PingFang TC"/>
+                <a:cs typeface="PingFang TC"/>
+              </a:rPr>
+              <a:t>11</a:t>
+            </a:r>
+          </a:p>
+        </p:txBody>
+      </p:sp>
+      <p:sp>
+        <p:nvSpPr>
+          <p:cNvPr id="31" name="矩形 30">
+            <a:extLst>
+              <a:ext uri="{FF2B5EF4-FFF2-40B4-BE49-F238E27FC236}">
+                <a16:creationId xmlns:a16="http://schemas.microsoft.com/office/drawing/2014/main" id="{3D123B31-E1D9-9D79-4912-FEEB8703804E}"/>
+              </a:ext>
+            </a:extLst>
+          </p:cNvPr>
+          <p:cNvSpPr>
+            <a:spLocks noGrp="1"/>
+          </p:cNvSpPr>
+          <p:nvPr/>
+        </p:nvSpPr>
+        <p:spPr>
+          <a:xfrm>
+            <a:off x="495300" y="6381750"/>
+            <a:ext cx="10287000" cy="190500"/>
+          </a:xfrm>
+          <a:prstGeom prst="rect">
+            <a:avLst/>
+          </a:prstGeom>
+          <a:noFill/>
+          <a:ln w="0">
+            <a:noFill/>
+            <a:prstDash val="solid"/>
+          </a:ln>
+        </p:spPr>
+        <p:txBody>
+          <a:bodyPr wrap="square" lIns="0" tIns="0" rIns="0" bIns="0" anchor="t">
+            <a:normAutofit/>
+          </a:bodyPr>
+          <a:lstStyle/>
           <a:p>
             <a:pPr algn="l">
               <a:buNone/>
-              <a:defRPr sz="1575" b="0">
-                <a:solidFill>
-                  <a:srgbClr val="111827"/>
-                </a:solidFill>
-                <a:latin typeface="PingFang TC"/>
-                <a:ea typeface="PingFang TC"/>
-                <a:cs typeface="PingFang TC"/>
-              </a:defRPr>
-            </a:pPr>
-            <a:r>
-              <a:rPr sz="1575" b="0">
-                <a:solidFill>
-                  <a:srgbClr val="111827"/>
-                </a:solidFill>
-                <a:latin typeface="PingFang TC"/>
-                <a:ea typeface="PingFang TC"/>
-                <a:cs typeface="PingFang TC"/>
-              </a:rPr>
-              <a:t>每一步有進入條件、驗收與退場。</a:t>
-            </a:r>
-          </a:p>
-        </p:txBody>
-      </p:sp>
-      <p:sp>
-        <p:nvSpPr>
-          <p:cNvPr id="9" name="矩形 8">
-            <a:extLst>
-              <a:ext uri="{FF2B5EF4-FFF2-40B4-BE49-F238E27FC236}">
-                <a16:creationId xmlns:a16="http://schemas.microsoft.com/office/drawing/2014/main" id="{8292ABD9-FD68-4253-8C17-DBAFEAF88EB1}"/>
-              </a:ext>
-            </a:extLst>
-          </p:cNvPr>
-          <p:cNvSpPr>
-            <a:spLocks noGrp="1"/>
-          </p:cNvSpPr>
-          <p:nvPr/>
-        </p:nvSpPr>
-        <p:spPr>
-          <a:xfrm>
-            <a:off x="4048125" y="1657350"/>
-            <a:ext cx="3333750" cy="3714750"/>
+              <a:defRPr sz="750" b="0">
+                <a:solidFill>
+                  <a:srgbClr val="667085"/>
+                </a:solidFill>
+                <a:latin typeface="PingFang TC"/>
+                <a:ea typeface="PingFang TC"/>
+                <a:cs typeface="PingFang TC"/>
+              </a:defRPr>
+            </a:pPr>
+            <a:r>
+              <a:rPr sz="750" b="0">
+                <a:solidFill>
+                  <a:srgbClr val="667085"/>
+                </a:solidFill>
+                <a:latin typeface="PingFang TC"/>
+                <a:ea typeface="PingFang TC"/>
+                <a:cs typeface="PingFang TC"/>
+              </a:rPr>
+              <a:t>來源：SLIDE-BRIEF-2026 §3.1–§3.2</a:t>
+            </a:r>
+          </a:p>
+        </p:txBody>
+      </p:sp>
+      <p:sp>
+        <p:nvSpPr>
+          <p:cNvPr id="5" name="矩形 4">
+            <a:extLst>
+              <a:ext uri="{FF2B5EF4-FFF2-40B4-BE49-F238E27FC236}">
+                <a16:creationId xmlns:a16="http://schemas.microsoft.com/office/drawing/2014/main" id="{C2FBB8DB-0629-BF5C-1C44-4E8B02B6C41C}"/>
+              </a:ext>
+            </a:extLst>
+          </p:cNvPr>
+          <p:cNvSpPr>
+            <a:spLocks noGrp="1"/>
+          </p:cNvSpPr>
+          <p:nvPr/>
+        </p:nvSpPr>
+        <p:spPr>
+          <a:xfrm>
+            <a:off x="495299" y="1571625"/>
+            <a:ext cx="9470335" cy="2036264"/>
           </a:xfrm>
           <a:prstGeom prst="rect">
             <a:avLst/>
@@ -3070,22 +2997,22 @@
       </p:sp>
       <p:sp>
         <p:nvSpPr>
-          <p:cNvPr id="10" name="矩形 9">
-            <a:extLst>
-              <a:ext uri="{FF2B5EF4-FFF2-40B4-BE49-F238E27FC236}">
-                <a16:creationId xmlns:a16="http://schemas.microsoft.com/office/drawing/2014/main" id="{3149B693-A121-413E-BE44-323A03510573}"/>
-              </a:ext>
-            </a:extLst>
-          </p:cNvPr>
-          <p:cNvSpPr>
-            <a:spLocks noGrp="1"/>
-          </p:cNvSpPr>
-          <p:nvPr/>
-        </p:nvSpPr>
-        <p:spPr>
-          <a:xfrm>
-            <a:off x="4048125" y="1657350"/>
-            <a:ext cx="66675" cy="3714750"/>
+          <p:cNvPr id="6" name="矩形 5">
+            <a:extLst>
+              <a:ext uri="{FF2B5EF4-FFF2-40B4-BE49-F238E27FC236}">
+                <a16:creationId xmlns:a16="http://schemas.microsoft.com/office/drawing/2014/main" id="{63EDE472-0516-5631-6313-05CAB2963804}"/>
+              </a:ext>
+            </a:extLst>
+          </p:cNvPr>
+          <p:cNvSpPr>
+            <a:spLocks noGrp="1"/>
+          </p:cNvSpPr>
+          <p:nvPr/>
+        </p:nvSpPr>
+        <p:spPr>
+          <a:xfrm>
+            <a:off x="495300" y="1571625"/>
+            <a:ext cx="101048" cy="2036259"/>
           </a:xfrm>
           <a:prstGeom prst="rect">
             <a:avLst/>
@@ -3108,21 +3035,21 @@
       </p:sp>
       <p:sp>
         <p:nvSpPr>
-          <p:cNvPr id="11" name="矩形 10">
-            <a:extLst>
-              <a:ext uri="{FF2B5EF4-FFF2-40B4-BE49-F238E27FC236}">
-                <a16:creationId xmlns:a16="http://schemas.microsoft.com/office/drawing/2014/main" id="{3036BEC3-68A3-467C-B97D-7A5774872029}"/>
-              </a:ext>
-            </a:extLst>
-          </p:cNvPr>
-          <p:cNvSpPr>
-            <a:spLocks noGrp="1"/>
-          </p:cNvSpPr>
-          <p:nvPr/>
-        </p:nvSpPr>
-        <p:spPr>
-          <a:xfrm>
-            <a:off x="4276725" y="1866900"/>
+          <p:cNvPr id="7" name="矩形 6">
+            <a:extLst>
+              <a:ext uri="{FF2B5EF4-FFF2-40B4-BE49-F238E27FC236}">
+                <a16:creationId xmlns:a16="http://schemas.microsoft.com/office/drawing/2014/main" id="{BA2991DA-7C8D-11CB-0C37-4292420F06E0}"/>
+              </a:ext>
+            </a:extLst>
+          </p:cNvPr>
+          <p:cNvSpPr>
+            <a:spLocks noGrp="1"/>
+          </p:cNvSpPr>
+          <p:nvPr/>
+        </p:nvSpPr>
+        <p:spPr>
+          <a:xfrm>
+            <a:off x="723900" y="1781175"/>
             <a:ext cx="2876550" cy="342900"/>
           </a:xfrm>
           <a:prstGeom prst="rect">
@@ -3152,7 +3079,7 @@
               </a:defRPr>
             </a:pPr>
             <a:r>
-              <a:rPr sz="1725" b="1">
+              <a:rPr sz="1725" b="1" dirty="0" err="1">
                 <a:solidFill>
                   <a:srgbClr val="111827"/>
                 </a:solidFill>
@@ -3162,116 +3089,7 @@
               </a:rPr>
               <a:t>產品期待</a:t>
             </a:r>
-          </a:p>
-        </p:txBody>
-      </p:sp>
-      <p:sp>
-        <p:nvSpPr>
-          <p:cNvPr id="12" name="矩形 11">
-            <a:extLst>
-              <a:ext uri="{FF2B5EF4-FFF2-40B4-BE49-F238E27FC236}">
-                <a16:creationId xmlns:a16="http://schemas.microsoft.com/office/drawing/2014/main" id="{4C1FAD88-68DA-466A-AD80-232D611C1853}"/>
-              </a:ext>
-            </a:extLst>
-          </p:cNvPr>
-          <p:cNvSpPr>
-            <a:spLocks noGrp="1"/>
-          </p:cNvSpPr>
-          <p:nvPr/>
-        </p:nvSpPr>
-        <p:spPr>
-          <a:xfrm>
-            <a:off x="4276725" y="2305050"/>
-            <a:ext cx="2876550" cy="2895600"/>
-          </a:xfrm>
-          <a:prstGeom prst="rect">
-            <a:avLst/>
-          </a:prstGeom>
-          <a:noFill/>
-          <a:ln w="0">
-            <a:noFill/>
-            <a:prstDash val="solid"/>
-          </a:ln>
-        </p:spPr>
-        <p:txBody>
-          <a:bodyPr wrap="square" lIns="0" tIns="0" rIns="0" bIns="0" anchor="t">
-            <a:normAutofit/>
-          </a:bodyPr>
-          <a:lstStyle/>
-          <a:p>
-            <a:pPr algn="l">
-              <a:buNone/>
-              <a:defRPr sz="1500" b="0">
-                <a:solidFill>
-                  <a:srgbClr val="111827"/>
-                </a:solidFill>
-                <a:latin typeface="PingFang TC"/>
-                <a:ea typeface="PingFang TC"/>
-                <a:cs typeface="PingFang TC"/>
-              </a:defRPr>
-            </a:pPr>
-            <a:r>
-              <a:rPr sz="1500" b="0">
-                <a:solidFill>
-                  <a:srgbClr val="111827"/>
-                </a:solidFill>
-                <a:latin typeface="PingFang TC"/>
-                <a:ea typeface="PingFang TC"/>
-                <a:cs typeface="PingFang TC"/>
-              </a:rPr>
-              <a:t>- Database Self-Service</a:t>
-            </a:r>
-          </a:p>
-          <a:p>
-            <a:pPr algn="l">
-              <a:buNone/>
-              <a:defRPr sz="1500" b="0">
-                <a:solidFill>
-                  <a:srgbClr val="111827"/>
-                </a:solidFill>
-                <a:latin typeface="PingFang TC"/>
-                <a:ea typeface="PingFang TC"/>
-                <a:cs typeface="PingFang TC"/>
-              </a:defRPr>
-            </a:pPr>
-            <a:r>
-              <a:rPr sz="1500" b="0">
-                <a:solidFill>
-                  <a:srgbClr val="111827"/>
-                </a:solidFill>
-                <a:latin typeface="PingFang TC"/>
-                <a:ea typeface="PingFang TC"/>
-                <a:cs typeface="PingFang TC"/>
-              </a:rPr>
-              <a:t>- EDC 資源活化</a:t>
-            </a:r>
-          </a:p>
-          <a:p>
-            <a:pPr algn="l">
-              <a:buNone/>
-              <a:defRPr sz="1500" b="0">
-                <a:solidFill>
-                  <a:srgbClr val="111827"/>
-                </a:solidFill>
-                <a:latin typeface="PingFang TC"/>
-                <a:ea typeface="PingFang TC"/>
-                <a:cs typeface="PingFang TC"/>
-              </a:defRPr>
-            </a:pPr>
-            <a:r>
-              <a:rPr sz="1500" b="0">
-                <a:solidFill>
-                  <a:srgbClr val="111827"/>
-                </a:solidFill>
-                <a:latin typeface="PingFang TC"/>
-                <a:ea typeface="PingFang TC"/>
-                <a:cs typeface="PingFang TC"/>
-              </a:rPr>
-              <a:t>- Observability</a:t>
-            </a:r>
-          </a:p>
-          <a:p>
-            <a:endParaRPr sz="1500" b="0">
+            <a:endParaRPr sz="1725" b="1" dirty="0">
               <a:solidFill>
                 <a:srgbClr val="111827"/>
               </a:solidFill>
@@ -3280,126 +3098,26 @@
               <a:cs typeface="PingFang TC"/>
             </a:endParaRPr>
           </a:p>
-          <a:p>
-            <a:pPr algn="l">
-              <a:buNone/>
-              <a:defRPr sz="1500" b="0">
-                <a:solidFill>
-                  <a:srgbClr val="111827"/>
-                </a:solidFill>
-                <a:latin typeface="PingFang TC"/>
-                <a:ea typeface="PingFang TC"/>
-                <a:cs typeface="PingFang TC"/>
-              </a:defRPr>
-            </a:pPr>
-            <a:r>
-              <a:rPr sz="1500" b="0">
-                <a:solidFill>
-                  <a:srgbClr val="111827"/>
-                </a:solidFill>
-                <a:latin typeface="PingFang TC"/>
-                <a:ea typeface="PingFang TC"/>
-                <a:cs typeface="PingFang TC"/>
-              </a:rPr>
-              <a:t>從 S0 起逐步交付。</a:t>
-            </a:r>
-          </a:p>
-        </p:txBody>
-      </p:sp>
-      <p:sp>
-        <p:nvSpPr>
-          <p:cNvPr id="13" name="矩形 12">
-            <a:extLst>
-              <a:ext uri="{FF2B5EF4-FFF2-40B4-BE49-F238E27FC236}">
-                <a16:creationId xmlns:a16="http://schemas.microsoft.com/office/drawing/2014/main" id="{70ABBF8B-4AF3-4C70-B5B5-95A9250B515D}"/>
-              </a:ext>
-            </a:extLst>
-          </p:cNvPr>
-          <p:cNvSpPr>
-            <a:spLocks noGrp="1"/>
-          </p:cNvSpPr>
-          <p:nvPr/>
-        </p:nvSpPr>
-        <p:spPr>
-          <a:xfrm>
-            <a:off x="7600950" y="1657350"/>
-            <a:ext cx="3638550" cy="3714750"/>
-          </a:xfrm>
-          <a:prstGeom prst="rect">
-            <a:avLst/>
-          </a:prstGeom>
-          <a:solidFill>
-            <a:srgbClr val="FFF4DF"/>
-          </a:solidFill>
-          <a:ln w="0">
-            <a:noFill/>
-            <a:prstDash val="solid"/>
-          </a:ln>
-        </p:spPr>
-        <p:txBody>
-          <a:bodyPr/>
-          <a:lstStyle/>
-          <a:p>
-            <a:endParaRPr/>
-          </a:p>
-        </p:txBody>
-      </p:sp>
-      <p:sp>
-        <p:nvSpPr>
-          <p:cNvPr id="14" name="矩形 13">
-            <a:extLst>
-              <a:ext uri="{FF2B5EF4-FFF2-40B4-BE49-F238E27FC236}">
-                <a16:creationId xmlns:a16="http://schemas.microsoft.com/office/drawing/2014/main" id="{161D8B7C-1F9B-473F-9829-643838A221B9}"/>
-              </a:ext>
-            </a:extLst>
-          </p:cNvPr>
-          <p:cNvSpPr>
-            <a:spLocks noGrp="1"/>
-          </p:cNvSpPr>
-          <p:nvPr/>
-        </p:nvSpPr>
-        <p:spPr>
-          <a:xfrm>
-            <a:off x="7600950" y="1657350"/>
-            <a:ext cx="66675" cy="3714750"/>
-          </a:xfrm>
-          <a:prstGeom prst="rect">
-            <a:avLst/>
-          </a:prstGeom>
-          <a:solidFill>
-            <a:srgbClr val="D97706"/>
-          </a:solidFill>
-          <a:ln w="0">
-            <a:noFill/>
-            <a:prstDash val="solid"/>
-          </a:ln>
-        </p:spPr>
-        <p:txBody>
-          <a:bodyPr/>
-          <a:lstStyle/>
-          <a:p>
-            <a:endParaRPr/>
-          </a:p>
-        </p:txBody>
-      </p:sp>
-      <p:sp>
-        <p:nvSpPr>
-          <p:cNvPr id="15" name="矩形 14">
-            <a:extLst>
-              <a:ext uri="{FF2B5EF4-FFF2-40B4-BE49-F238E27FC236}">
-                <a16:creationId xmlns:a16="http://schemas.microsoft.com/office/drawing/2014/main" id="{DF301831-B083-40D1-B0E3-E840EAA0A21E}"/>
-              </a:ext>
-            </a:extLst>
-          </p:cNvPr>
-          <p:cNvSpPr>
-            <a:spLocks noGrp="1"/>
-          </p:cNvSpPr>
-          <p:nvPr/>
-        </p:nvSpPr>
-        <p:spPr>
-          <a:xfrm>
-            <a:off x="7829550" y="1866900"/>
-            <a:ext cx="3181350" cy="342900"/>
+        </p:txBody>
+      </p:sp>
+      <p:sp>
+        <p:nvSpPr>
+          <p:cNvPr id="32" name="矩形 31">
+            <a:extLst>
+              <a:ext uri="{FF2B5EF4-FFF2-40B4-BE49-F238E27FC236}">
+                <a16:creationId xmlns:a16="http://schemas.microsoft.com/office/drawing/2014/main" id="{929D75FF-FD61-19D4-A755-9C029CCFC797}"/>
+              </a:ext>
+            </a:extLst>
+          </p:cNvPr>
+          <p:cNvSpPr>
+            <a:spLocks noGrp="1"/>
+          </p:cNvSpPr>
+          <p:nvPr/>
+        </p:nvSpPr>
+        <p:spPr>
+          <a:xfrm>
+            <a:off x="723900" y="2219325"/>
+            <a:ext cx="2876550" cy="2895600"/>
           </a:xfrm>
           <a:prstGeom prst="rect">
             <a:avLst/>
@@ -3418,7 +3136,7 @@
           <a:p>
             <a:pPr algn="l">
               <a:buNone/>
-              <a:defRPr sz="1725" b="1">
+              <a:defRPr sz="1500" b="0">
                 <a:solidFill>
                   <a:srgbClr val="111827"/>
                 </a:solidFill>
@@ -3428,7 +3146,7 @@
               </a:defRPr>
             </a:pPr>
             <a:r>
-              <a:rPr sz="1725" b="1">
+              <a:rPr sz="1500" b="0" dirty="0">
                 <a:solidFill>
                   <a:srgbClr val="111827"/>
                 </a:solidFill>
@@ -3436,44 +3154,9 @@
                 <a:ea typeface="PingFang TC"/>
                 <a:cs typeface="PingFang TC"/>
               </a:rPr>
-              <a:t>維運後勤</a:t>
-            </a:r>
-          </a:p>
-        </p:txBody>
-      </p:sp>
-      <p:sp>
-        <p:nvSpPr>
-          <p:cNvPr id="16" name="矩形 15">
-            <a:extLst>
-              <a:ext uri="{FF2B5EF4-FFF2-40B4-BE49-F238E27FC236}">
-                <a16:creationId xmlns:a16="http://schemas.microsoft.com/office/drawing/2014/main" id="{4EC0BE5D-A8FA-47AA-AD83-B56A66AEE79F}"/>
-              </a:ext>
-            </a:extLst>
-          </p:cNvPr>
-          <p:cNvSpPr>
-            <a:spLocks noGrp="1"/>
-          </p:cNvSpPr>
-          <p:nvPr/>
-        </p:nvSpPr>
-        <p:spPr>
-          <a:xfrm>
-            <a:off x="7829550" y="2305050"/>
-            <a:ext cx="3181350" cy="2895600"/>
-          </a:xfrm>
-          <a:prstGeom prst="rect">
-            <a:avLst/>
-          </a:prstGeom>
-          <a:noFill/>
-          <a:ln w="0">
-            <a:noFill/>
-            <a:prstDash val="solid"/>
-          </a:ln>
-        </p:spPr>
-        <p:txBody>
-          <a:bodyPr wrap="square" lIns="0" tIns="0" rIns="0" bIns="0" anchor="t">
-            <a:normAutofit/>
-          </a:bodyPr>
-          <a:lstStyle/>
+              <a:t>- Database Self-Service</a:t>
+            </a:r>
+          </a:p>
           <a:p>
             <a:pPr algn="l">
               <a:buNone/>
@@ -3487,6 +3170,17 @@
               </a:defRPr>
             </a:pPr>
             <a:r>
+              <a:rPr sz="1500" b="0" dirty="0">
+                <a:solidFill>
+                  <a:srgbClr val="111827"/>
+                </a:solidFill>
+                <a:latin typeface="PingFang TC"/>
+                <a:ea typeface="PingFang TC"/>
+                <a:cs typeface="PingFang TC"/>
+              </a:rPr>
+              <a:t>- EDC </a:t>
+            </a:r>
+            <a:r>
               <a:rPr sz="1500" b="0" dirty="0" err="1">
                 <a:solidFill>
                   <a:srgbClr val="111827"/>
@@ -3495,53 +3189,7 @@
                 <a:ea typeface="PingFang TC"/>
                 <a:cs typeface="PingFang TC"/>
               </a:rPr>
-              <a:t>自控：PITR、Online</a:t>
-            </a:r>
-            <a:r>
-              <a:rPr sz="1500" b="0" dirty="0">
-                <a:solidFill>
-                  <a:srgbClr val="111827"/>
-                </a:solidFill>
-                <a:latin typeface="PingFang TC"/>
-                <a:ea typeface="PingFang TC"/>
-                <a:cs typeface="PingFang TC"/>
-              </a:rPr>
-              <a:t> DDL</a:t>
-            </a:r>
-          </a:p>
-          <a:p>
-            <a:pPr algn="l">
-              <a:buNone/>
-              <a:defRPr sz="1500" b="0">
-                <a:solidFill>
-                  <a:srgbClr val="111827"/>
-                </a:solidFill>
-                <a:latin typeface="PingFang TC"/>
-                <a:ea typeface="PingFang TC"/>
-                <a:cs typeface="PingFang TC"/>
-              </a:defRPr>
-            </a:pPr>
-            <a:r>
-              <a:rPr sz="1500" b="0" dirty="0" err="1">
-                <a:solidFill>
-                  <a:srgbClr val="111827"/>
-                </a:solidFill>
-                <a:latin typeface="PingFang TC"/>
-                <a:ea typeface="PingFang TC"/>
-                <a:cs typeface="PingFang TC"/>
-              </a:rPr>
-              <a:t>協作：相容性與隔離</a:t>
-            </a:r>
-            <a:r>
-              <a:rPr lang="zh-TW" altLang="en-US" sz="1500" b="0" dirty="0">
-                <a:solidFill>
-                  <a:srgbClr val="111827"/>
-                </a:solidFill>
-                <a:latin typeface="PingFang TC"/>
-                <a:ea typeface="PingFang TC"/>
-                <a:cs typeface="PingFang TC"/>
-              </a:rPr>
-              <a:t>層級設定</a:t>
+              <a:t>資源活化</a:t>
             </a:r>
             <a:endParaRPr sz="1500" b="0" dirty="0">
               <a:solidFill>
@@ -3565,7 +3213,7 @@
               </a:defRPr>
             </a:pPr>
             <a:r>
-              <a:rPr sz="1500" b="0" dirty="0" err="1">
+              <a:rPr sz="1500" b="0" dirty="0">
                 <a:solidFill>
                   <a:srgbClr val="111827"/>
                 </a:solidFill>
@@ -3573,30 +3221,10 @@
                 <a:ea typeface="PingFang TC"/>
                 <a:cs typeface="PingFang TC"/>
               </a:rPr>
-              <a:t>原廠：</a:t>
-            </a:r>
-            <a:r>
-              <a:rPr lang="en-US" sz="1500" dirty="0" err="1">
-                <a:solidFill>
-                  <a:srgbClr val="111827"/>
-                </a:solidFill>
-                <a:latin typeface="PingFang TC"/>
-                <a:ea typeface="PingFang TC"/>
-                <a:cs typeface="PingFang TC"/>
-              </a:rPr>
-              <a:t>協作</a:t>
-            </a:r>
-            <a:r>
-              <a:rPr sz="1500" b="0" dirty="0" err="1">
-                <a:solidFill>
-                  <a:srgbClr val="111827"/>
-                </a:solidFill>
-                <a:latin typeface="PingFang TC"/>
-                <a:ea typeface="PingFang TC"/>
-                <a:cs typeface="PingFang TC"/>
-              </a:rPr>
-              <a:t>方案、SLA</a:t>
-            </a:r>
+              <a:t>- Observability</a:t>
+            </a:r>
+          </a:p>
+          <a:p>
             <a:endParaRPr sz="1500" b="0" dirty="0">
               <a:solidFill>
                 <a:srgbClr val="111827"/>
@@ -3618,27 +3246,28 @@
                 <a:cs typeface="PingFang TC"/>
               </a:defRPr>
             </a:pPr>
-            <a:endParaRPr sz="1500" b="0" dirty="0">
-              <a:solidFill>
-                <a:srgbClr val="111827"/>
-              </a:solidFill>
-              <a:latin typeface="PingFang TC"/>
-              <a:ea typeface="PingFang TC"/>
-              <a:cs typeface="PingFang TC"/>
-            </a:endParaRPr>
-          </a:p>
-          <a:p>
-            <a:pPr algn="l">
-              <a:buNone/>
-              <a:defRPr sz="1500" b="0">
+            <a:r>
+              <a:rPr sz="1500" b="0" dirty="0" err="1">
                 <a:solidFill>
                   <a:srgbClr val="111827"/>
                 </a:solidFill>
                 <a:latin typeface="PingFang TC"/>
                 <a:ea typeface="PingFang TC"/>
                 <a:cs typeface="PingFang TC"/>
-              </a:defRPr>
-            </a:pPr>
+              </a:rPr>
+              <a:t>從</a:t>
+            </a:r>
+            <a:r>
+              <a:rPr sz="1500" b="0" dirty="0">
+                <a:solidFill>
+                  <a:srgbClr val="111827"/>
+                </a:solidFill>
+                <a:latin typeface="PingFang TC"/>
+                <a:ea typeface="PingFang TC"/>
+                <a:cs typeface="PingFang TC"/>
+              </a:rPr>
+              <a:t> S0 </a:t>
+            </a:r>
             <a:r>
               <a:rPr sz="1500" b="0" dirty="0" err="1">
                 <a:solidFill>
@@ -3648,10 +3277,10 @@
                 <a:ea typeface="PingFang TC"/>
                 <a:cs typeface="PingFang TC"/>
               </a:rPr>
-              <a:t>先建立</a:t>
-            </a:r>
-            <a:r>
-              <a:rPr lang="zh-TW" altLang="en-US" sz="1500" b="0" dirty="0">
+              <a:t>起逐步交付</a:t>
+            </a:r>
+            <a:r>
+              <a:rPr sz="1500" b="0" dirty="0">
                 <a:solidFill>
                   <a:srgbClr val="111827"/>
                 </a:solidFill>
@@ -3659,88 +3288,7 @@
                 <a:ea typeface="PingFang TC"/>
                 <a:cs typeface="PingFang TC"/>
               </a:rPr>
-              <a:t>維運</a:t>
-            </a:r>
-            <a:r>
-              <a:rPr sz="1500" b="0" dirty="0" err="1">
-                <a:solidFill>
-                  <a:srgbClr val="111827"/>
-                </a:solidFill>
-                <a:latin typeface="PingFang TC"/>
-                <a:ea typeface="PingFang TC"/>
-                <a:cs typeface="PingFang TC"/>
-              </a:rPr>
-              <a:t>能力，不預設採購</a:t>
-            </a:r>
-            <a:r>
-              <a:rPr sz="1500" b="0" dirty="0">
-                <a:solidFill>
-                  <a:srgbClr val="111827"/>
-                </a:solidFill>
-                <a:latin typeface="PingFang TC"/>
-                <a:ea typeface="PingFang TC"/>
-                <a:cs typeface="PingFang TC"/>
-              </a:rPr>
               <a:t>。</a:t>
-            </a:r>
-          </a:p>
-        </p:txBody>
-      </p:sp>
-      <p:sp>
-        <p:nvSpPr>
-          <p:cNvPr id="18" name="矩形 17">
-            <a:extLst>
-              <a:ext uri="{FF2B5EF4-FFF2-40B4-BE49-F238E27FC236}">
-                <a16:creationId xmlns:a16="http://schemas.microsoft.com/office/drawing/2014/main" id="{AEC38EF6-F9A3-4C59-BA64-5B3ECCAA91A4}"/>
-              </a:ext>
-            </a:extLst>
-          </p:cNvPr>
-          <p:cNvSpPr>
-            <a:spLocks noGrp="1"/>
-          </p:cNvSpPr>
-          <p:nvPr/>
-        </p:nvSpPr>
-        <p:spPr>
-          <a:xfrm>
-            <a:off x="495300" y="6381750"/>
-            <a:ext cx="10287000" cy="190500"/>
-          </a:xfrm>
-          <a:prstGeom prst="rect">
-            <a:avLst/>
-          </a:prstGeom>
-          <a:noFill/>
-          <a:ln w="0">
-            <a:noFill/>
-            <a:prstDash val="solid"/>
-          </a:ln>
-        </p:spPr>
-        <p:txBody>
-          <a:bodyPr wrap="square" lIns="0" tIns="0" rIns="0" bIns="0" anchor="t">
-            <a:normAutofit/>
-          </a:bodyPr>
-          <a:lstStyle/>
-          <a:p>
-            <a:pPr algn="l">
-              <a:buNone/>
-              <a:defRPr sz="750" b="0">
-                <a:solidFill>
-                  <a:srgbClr val="667085"/>
-                </a:solidFill>
-                <a:latin typeface="PingFang TC"/>
-                <a:ea typeface="PingFang TC"/>
-                <a:cs typeface="PingFang TC"/>
-              </a:defRPr>
-            </a:pPr>
-            <a:r>
-              <a:rPr sz="750" b="0">
-                <a:solidFill>
-                  <a:srgbClr val="667085"/>
-                </a:solidFill>
-                <a:latin typeface="PingFang TC"/>
-                <a:ea typeface="PingFang TC"/>
-                <a:cs typeface="PingFang TC"/>
-              </a:rPr>
-              <a:t>來源：SLIDE-BRIEF-2026 §3.1、§3.3、§3.4</a:t>
             </a:r>
           </a:p>
         </p:txBody>
@@ -3748,7 +3296,7 @@
     </p:spTree>
     <p:extLst>
       <p:ext uri="{BB962C8B-B14F-4D97-AF65-F5344CB8AC3E}">
-        <p14:creationId xmlns:p14="http://schemas.microsoft.com/office/powerpoint/2010/main" val="87926805"/>
+        <p14:creationId xmlns:p14="http://schemas.microsoft.com/office/powerpoint/2010/main" val="884321466"/>
       </p:ext>
     </p:extLst>
   </p:cSld>
@@ -20675,6 +20223,19 @@
               <a:t>MySQL </a:t>
             </a:r>
             <a:r>
+              <a:rPr lang="en-US" b="1" dirty="0" err="1">
+                <a:solidFill>
+                  <a:schemeClr val="accent6">
+                    <a:lumMod val="50000"/>
+                  </a:schemeClr>
+                </a:solidFill>
+                <a:latin typeface="PingFang TC"/>
+                <a:ea typeface="PingFang TC"/>
+                <a:cs typeface="PingFang TC"/>
+              </a:rPr>
+              <a:t>相容</a:t>
+            </a:r>
+            <a:r>
               <a:rPr lang="zh-TW" altLang="en-US" b="1" dirty="0">
                 <a:solidFill>
                   <a:schemeClr val="accent6">
@@ -20870,7 +20431,7 @@
                 <a:ea typeface="PingFang TC"/>
                 <a:cs typeface="PingFang TC"/>
               </a:rPr>
-              <a:t>從「技術能不能做」轉向「業務是否需要、應用是否適配、投入是否值得</a:t>
+              <a:t>從「技術能不能做」轉向「業務是否需要、應用是否適配、投入是否</a:t>
             </a:r>
             <a:r>
               <a:rPr lang="zh-TW" altLang="en-US" b="1" dirty="0">
@@ -20881,7 +20442,7 @@
                 <a:ea typeface="PingFang TC"/>
                 <a:cs typeface="PingFang TC"/>
               </a:rPr>
-              <a:t>。</a:t>
+              <a:t>值得」。</a:t>
             </a:r>
             <a:endParaRPr sz="1800" b="1" dirty="0">
               <a:solidFill>
@@ -23651,7 +23212,7 @@
               </a:defRPr>
             </a:pPr>
             <a:r>
-              <a:rPr sz="1725" b="1">
+              <a:rPr sz="1725" b="1" dirty="0" err="1">
                 <a:solidFill>
                   <a:srgbClr val="111827"/>
                 </a:solidFill>
@@ -23661,6 +23222,14 @@
               </a:rPr>
               <a:t>策略層</a:t>
             </a:r>
+            <a:endParaRPr sz="1725" b="1" dirty="0">
+              <a:solidFill>
+                <a:srgbClr val="111827"/>
+              </a:solidFill>
+              <a:latin typeface="PingFang TC"/>
+              <a:ea typeface="PingFang TC"/>
+              <a:cs typeface="PingFang TC"/>
+            </a:endParaRPr>
           </a:p>
         </p:txBody>
       </p:sp>
@@ -23710,7 +23279,7 @@
               </a:defRPr>
             </a:pPr>
             <a:r>
-              <a:rPr sz="1500" b="0">
+              <a:rPr sz="1500" b="0" dirty="0" err="1">
                 <a:solidFill>
                   <a:srgbClr val="111827"/>
                 </a:solidFill>
@@ -23718,7 +23287,40 @@
                 <a:ea typeface="PingFang TC"/>
                 <a:cs typeface="PingFang TC"/>
               </a:rPr>
-              <a:t>隔離應用與基礎建設的直接關連，讓應用具備可攜性。</a:t>
+              <a:t>讓應用</a:t>
+            </a:r>
+            <a:r>
+              <a:rPr lang="zh-TW" altLang="en-US" sz="1500" b="0" dirty="0">
+                <a:solidFill>
+                  <a:srgbClr val="111827"/>
+                </a:solidFill>
+                <a:latin typeface="PingFang TC"/>
+                <a:ea typeface="PingFang TC"/>
+                <a:cs typeface="PingFang TC"/>
+              </a:rPr>
+              <a:t>及資料</a:t>
+            </a:r>
+            <a:r>
+              <a:rPr sz="1500" b="0" dirty="0" err="1">
+                <a:solidFill>
+                  <a:srgbClr val="111827"/>
+                </a:solidFill>
+                <a:latin typeface="PingFang TC"/>
+                <a:ea typeface="PingFang TC"/>
+                <a:cs typeface="PingFang TC"/>
+              </a:rPr>
+              <a:t>具備可攜性</a:t>
+            </a:r>
+            <a:r>
+              <a:rPr sz="1500" b="0" dirty="0">
+                <a:solidFill>
+                  <a:srgbClr val="111827"/>
+                </a:solidFill>
+                <a:latin typeface="PingFang TC"/>
+                <a:ea typeface="PingFang TC"/>
+                <a:cs typeface="PingFang TC"/>
+              </a:rPr>
+              <a:t>。</a:t>
             </a:r>
           </a:p>
         </p:txBody>
@@ -23904,7 +23506,7 @@
               </a:defRPr>
             </a:pPr>
             <a:r>
-              <a:rPr sz="1500" b="0">
+              <a:rPr sz="1500" b="0" dirty="0" err="1">
                 <a:solidFill>
                   <a:srgbClr val="111827"/>
                 </a:solidFill>
@@ -23912,7 +23514,18 @@
                 <a:ea typeface="PingFang TC"/>
                 <a:cs typeface="PingFang TC"/>
               </a:rPr>
-              <a:t>期待封站或機房維護時，關鍵服務客戶不受影響。</a:t>
+              <a:t>期待封站或機房維護時，關鍵服務客戶不受影響</a:t>
+            </a:r>
+            <a:r>
+              <a:rPr sz="1500" b="0" dirty="0">
+                <a:solidFill>
+                  <a:srgbClr val="111827"/>
+                </a:solidFill>
+                <a:latin typeface="PingFang TC"/>
+                <a:ea typeface="PingFang TC"/>
+                <a:cs typeface="PingFang TC"/>
+              </a:rPr>
+              <a:t>。</a:t>
             </a:r>
           </a:p>
         </p:txBody>
@@ -24098,7 +23711,7 @@
               </a:defRPr>
             </a:pPr>
             <a:r>
-              <a:rPr sz="1500" b="0">
+              <a:rPr sz="1500" b="0" dirty="0" err="1">
                 <a:solidFill>
                   <a:srgbClr val="111827"/>
                 </a:solidFill>
@@ -24106,7 +23719,18 @@
                 <a:ea typeface="PingFang TC"/>
                 <a:cs typeface="PingFang TC"/>
               </a:rPr>
-              <a:t>停機維護是內部作業，不應轉嫁為客戶權益損失。</a:t>
+              <a:t>停機維護是內部作業，不轉嫁為客戶權益損失</a:t>
+            </a:r>
+            <a:r>
+              <a:rPr sz="1500" b="0" dirty="0">
+                <a:solidFill>
+                  <a:srgbClr val="111827"/>
+                </a:solidFill>
+                <a:latin typeface="PingFang TC"/>
+                <a:ea typeface="PingFang TC"/>
+                <a:cs typeface="PingFang TC"/>
+              </a:rPr>
+              <a:t>。</a:t>
             </a:r>
           </a:p>
         </p:txBody>
@@ -26078,7 +25702,7 @@
               </a:defRPr>
             </a:pPr>
             <a:r>
-              <a:rPr sz="3150" b="1">
+              <a:rPr sz="3150" b="1" dirty="0" err="1">
                 <a:solidFill>
                   <a:srgbClr val="101828"/>
                 </a:solidFill>
@@ -26086,7 +25710,18 @@
                 <a:ea typeface="Arial"/>
                 <a:cs typeface="Arial"/>
               </a:rPr>
-              <a:t>目標不變；交付路線改為 A/S → A/A (RO)</a:t>
+              <a:t>目標不變；交付路線改為</a:t>
+            </a:r>
+            <a:r>
+              <a:rPr sz="3150" b="1" dirty="0">
+                <a:solidFill>
+                  <a:srgbClr val="101828"/>
+                </a:solidFill>
+                <a:latin typeface="Arial"/>
+                <a:ea typeface="Arial"/>
+                <a:cs typeface="Arial"/>
+              </a:rPr>
+              <a:t> A/S → A/A (RO)</a:t>
             </a:r>
           </a:p>
         </p:txBody>
@@ -26299,7 +25934,7 @@
               <a:t>；</a:t>
             </a:r>
             <a:r>
-              <a:rPr sz="1500" b="1" dirty="0" err="1">
+              <a:rPr lang="en-US" sz="1500" b="1" dirty="0" err="1">
                 <a:solidFill>
                   <a:srgbClr val="101828"/>
                 </a:solidFill>
@@ -26307,7 +25942,7 @@
                 <a:ea typeface="Arial"/>
                 <a:cs typeface="Arial"/>
               </a:rPr>
-              <a:t>通過後才進入</a:t>
+              <a:t>下一個挑戰是</a:t>
             </a:r>
             <a:r>
               <a:rPr sz="1500" b="1" dirty="0">
@@ -26410,6 +26045,70 @@
               </a:rPr>
               <a:t>。</a:t>
             </a:r>
+            <a:br>
+              <a:rPr lang="en-US" sz="1500" b="1" dirty="0">
+                <a:solidFill>
+                  <a:srgbClr val="101828"/>
+                </a:solidFill>
+                <a:latin typeface="Arial"/>
+                <a:ea typeface="Arial"/>
+                <a:cs typeface="Arial"/>
+              </a:rPr>
+            </a:br>
+            <a:r>
+              <a:rPr lang="en-US" sz="1500" b="1" dirty="0">
+                <a:solidFill>
+                  <a:srgbClr val="101828"/>
+                </a:solidFill>
+                <a:latin typeface="Arial"/>
+                <a:ea typeface="Arial"/>
+                <a:cs typeface="Arial"/>
+              </a:rPr>
+              <a:t>- </a:t>
+            </a:r>
+            <a:r>
+              <a:rPr lang="en-US" sz="1500" b="1" dirty="0">
+                <a:solidFill>
+                  <a:srgbClr val="101828"/>
+                </a:solidFill>
+                <a:latin typeface="Arial"/>
+                <a:ea typeface="Arial"/>
+                <a:cs typeface="Arial"/>
+                <a:hlinkClick r:id="rId3" action="ppaction://hlinksldjump"/>
+              </a:rPr>
+              <a:t>決策表 1</a:t>
+            </a:r>
+            <a:r>
+              <a:rPr lang="en-US" sz="1500" b="1" dirty="0">
+                <a:solidFill>
+                  <a:srgbClr val="101828"/>
+                </a:solidFill>
+                <a:latin typeface="Arial"/>
+                <a:ea typeface="Arial"/>
+                <a:cs typeface="Arial"/>
+              </a:rPr>
+              <a:t> / </a:t>
+            </a:r>
+            <a:r>
+              <a:rPr lang="en-US" sz="1500" b="1" dirty="0">
+                <a:solidFill>
+                  <a:srgbClr val="101828"/>
+                </a:solidFill>
+                <a:latin typeface="Arial"/>
+                <a:ea typeface="Arial"/>
+                <a:cs typeface="Arial"/>
+                <a:hlinkClick r:id="rId4" action="ppaction://hlinksldjump"/>
+              </a:rPr>
+              <a:t>決策表 2</a:t>
+            </a:r>
+            <a:endParaRPr lang="zh-TW" altLang="en-US" sz="1500" b="1" dirty="0">
+              <a:solidFill>
+                <a:srgbClr val="101828"/>
+              </a:solidFill>
+              <a:latin typeface="Arial"/>
+              <a:ea typeface="Arial"/>
+              <a:cs typeface="Arial"/>
+            </a:endParaRPr>
           </a:p>
         </p:txBody>
       </p:sp>
@@ -26748,7 +26447,7 @@
               </a:defRPr>
             </a:pPr>
             <a:r>
-              <a:rPr sz="1050" b="0">
+              <a:rPr sz="1050" b="0" dirty="0" err="1">
                 <a:solidFill>
                   <a:srgbClr val="667085"/>
                 </a:solidFill>
@@ -26756,8 +26455,60 @@
                 <a:ea typeface="Arial"/>
                 <a:cs typeface="Arial"/>
               </a:rPr>
-              <a:t>低延遲參考；無 placement／near-read 等價能力</a:t>
-            </a:r>
+              <a:t>低延遲參考；無</a:t>
+            </a:r>
+            <a:r>
+              <a:rPr sz="1050" b="0" dirty="0">
+                <a:solidFill>
+                  <a:srgbClr val="667085"/>
+                </a:solidFill>
+                <a:latin typeface="Arial"/>
+                <a:ea typeface="Arial"/>
+                <a:cs typeface="Arial"/>
+              </a:rPr>
+              <a:t> </a:t>
+            </a:r>
+            <a:r>
+              <a:rPr sz="1050" b="0" dirty="0" err="1">
+                <a:solidFill>
+                  <a:srgbClr val="667085"/>
+                </a:solidFill>
+                <a:latin typeface="Arial"/>
+                <a:ea typeface="Arial"/>
+                <a:cs typeface="Arial"/>
+              </a:rPr>
+              <a:t>placement／near-read</a:t>
+            </a:r>
+            <a:r>
+              <a:rPr sz="1050" b="0" dirty="0">
+                <a:solidFill>
+                  <a:srgbClr val="667085"/>
+                </a:solidFill>
+                <a:latin typeface="Arial"/>
+                <a:ea typeface="Arial"/>
+                <a:cs typeface="Arial"/>
+              </a:rPr>
+              <a:t> </a:t>
+            </a:r>
+            <a:r>
+              <a:rPr sz="1050" b="0" dirty="0" err="1">
+                <a:solidFill>
+                  <a:srgbClr val="667085"/>
+                </a:solidFill>
+                <a:latin typeface="Arial"/>
+                <a:ea typeface="Arial"/>
+                <a:cs typeface="Arial"/>
+              </a:rPr>
+              <a:t>等價能力</a:t>
+            </a:r>
+            <a:endParaRPr sz="1050" b="0" dirty="0">
+              <a:solidFill>
+                <a:srgbClr val="667085"/>
+              </a:solidFill>
+              <a:latin typeface="Arial"/>
+              <a:ea typeface="Arial"/>
+              <a:cs typeface="Arial"/>
+            </a:endParaRPr>
           </a:p>
         </p:txBody>
       </p:sp>
@@ -26847,7 +26598,7 @@
               </a:defRPr>
             </a:pPr>
             <a:r>
-              <a:rPr sz="1500" b="1">
+              <a:rPr sz="1500" b="1" dirty="0" err="1">
                 <a:solidFill>
                   <a:srgbClr val="2563EB"/>
                 </a:solidFill>
@@ -26857,6 +26608,47 @@
               </a:rPr>
               <a:t>TiDB</a:t>
             </a:r>
+            <a:r>
+              <a:rPr lang="en-US" sz="1500" b="1" dirty="0">
+                <a:solidFill>
+                  <a:srgbClr val="2563EB"/>
+                </a:solidFill>
+                <a:latin typeface="Arial"/>
+                <a:ea typeface="Arial"/>
+                <a:cs typeface="Arial"/>
+              </a:rPr>
+              <a:t> (</a:t>
+            </a:r>
+            <a:r>
+              <a:rPr lang="en-US" sz="1500" b="1" dirty="0" err="1">
+                <a:solidFill>
+                  <a:srgbClr val="2563EB"/>
+                </a:solidFill>
+                <a:latin typeface="Arial"/>
+                <a:ea typeface="Arial"/>
+                <a:cs typeface="Arial"/>
+              </a:rPr>
+              <a:t>建議採用</a:t>
+            </a:r>
+            <a:r>
+              <a:rPr lang="en-US" sz="1500" b="1" dirty="0">
+                <a:solidFill>
+                  <a:srgbClr val="2563EB"/>
+                </a:solidFill>
+                <a:latin typeface="Arial"/>
+                <a:ea typeface="Arial"/>
+                <a:cs typeface="Arial"/>
+              </a:rPr>
+              <a:t>)</a:t>
+            </a:r>
+            <a:endParaRPr sz="1500" b="1" dirty="0">
+              <a:solidFill>
+                <a:srgbClr val="2563EB"/>
+              </a:solidFill>
+              <a:latin typeface="Arial"/>
+              <a:ea typeface="Arial"/>
+              <a:cs typeface="Arial"/>
+            </a:endParaRPr>
           </a:p>
         </p:txBody>
       </p:sp>
@@ -27093,7 +26885,7 @@
               </a:defRPr>
             </a:pPr>
             <a:r>
-              <a:rPr sz="1050" b="0">
+              <a:rPr sz="1050" b="0" dirty="0">
                 <a:solidFill>
                   <a:srgbClr val="667085"/>
                 </a:solidFill>
@@ -27101,8 +26893,141 @@
                 <a:ea typeface="Arial"/>
                 <a:cs typeface="Arial"/>
               </a:rPr>
-              <a:t>MySQL 主線；A/S → A/A (RO)</a:t>
-            </a:r>
+              <a:t>MySQL </a:t>
+            </a:r>
+            <a:r>
+              <a:rPr sz="1050" b="0" dirty="0" err="1">
+                <a:solidFill>
+                  <a:srgbClr val="667085"/>
+                </a:solidFill>
+                <a:latin typeface="Arial"/>
+                <a:ea typeface="Arial"/>
+                <a:cs typeface="Arial"/>
+              </a:rPr>
+              <a:t>主線；A</a:t>
+            </a:r>
+            <a:r>
+              <a:rPr sz="1050" b="0" dirty="0">
+                <a:solidFill>
+                  <a:srgbClr val="667085"/>
+                </a:solidFill>
+                <a:latin typeface="Arial"/>
+                <a:ea typeface="Arial"/>
+                <a:cs typeface="Arial"/>
+              </a:rPr>
+              <a:t>/S → A/A (RO)</a:t>
+            </a:r>
+            <a:endParaRPr lang="en-US" sz="1050" b="0" dirty="0">
+              <a:solidFill>
+                <a:srgbClr val="667085"/>
+              </a:solidFill>
+              <a:latin typeface="Arial"/>
+              <a:ea typeface="Arial"/>
+              <a:cs typeface="Arial"/>
+            </a:endParaRPr>
+          </a:p>
+          <a:p>
+            <a:pPr algn="l">
+              <a:lnSpc>
+                <a:spcPct val="105000"/>
+              </a:lnSpc>
+              <a:buNone/>
+              <a:defRPr sz="1050" b="0">
+                <a:solidFill>
+                  <a:srgbClr val="667085"/>
+                </a:solidFill>
+                <a:latin typeface="Arial"/>
+                <a:ea typeface="Arial"/>
+                <a:cs typeface="Arial"/>
+              </a:defRPr>
+            </a:pPr>
+            <a:endParaRPr lang="en-US" sz="1050" b="0" dirty="0">
+              <a:solidFill>
+                <a:srgbClr val="667085"/>
+              </a:solidFill>
+              <a:latin typeface="Arial"/>
+              <a:ea typeface="Arial"/>
+              <a:cs typeface="Arial"/>
+            </a:endParaRPr>
+          </a:p>
+          <a:p>
+            <a:pPr algn="l">
+              <a:lnSpc>
+                <a:spcPct val="105000"/>
+              </a:lnSpc>
+              <a:buNone/>
+              <a:defRPr sz="1050" b="0">
+                <a:solidFill>
+                  <a:srgbClr val="667085"/>
+                </a:solidFill>
+                <a:latin typeface="Arial"/>
+                <a:ea typeface="Arial"/>
+                <a:cs typeface="Arial"/>
+              </a:defRPr>
+            </a:pPr>
+            <a:r>
+              <a:rPr lang="en-US" altLang="zh-TW" sz="1050" b="0" dirty="0">
+                <a:solidFill>
+                  <a:srgbClr val="667085"/>
+                </a:solidFill>
+                <a:latin typeface="Arial"/>
+                <a:ea typeface="Arial"/>
+                <a:cs typeface="Arial"/>
+              </a:rPr>
+              <a:t>{FIXME} </a:t>
+            </a:r>
+            <a:r>
+              <a:rPr lang="zh-TW" altLang="en-US" sz="1050" b="0" dirty="0">
+                <a:solidFill>
+                  <a:srgbClr val="667085"/>
+                </a:solidFill>
+                <a:latin typeface="Arial"/>
+                <a:ea typeface="Arial"/>
+                <a:cs typeface="Arial"/>
+              </a:rPr>
+              <a:t>建議產品屬性</a:t>
+            </a:r>
+            <a:r>
+              <a:rPr lang="zh-TW" altLang="en-US" sz="1050" dirty="0">
+                <a:solidFill>
+                  <a:srgbClr val="667085"/>
+                </a:solidFill>
+                <a:latin typeface="Arial"/>
+                <a:ea typeface="Arial"/>
+                <a:cs typeface="Arial"/>
+              </a:rPr>
+              <a:t>符合</a:t>
+            </a:r>
+            <a:r>
+              <a:rPr lang="en-US" altLang="zh-TW" sz="1050" dirty="0">
+                <a:solidFill>
+                  <a:srgbClr val="667085"/>
+                </a:solidFill>
+                <a:latin typeface="Arial"/>
+                <a:ea typeface="Arial"/>
+                <a:cs typeface="Arial"/>
+              </a:rPr>
+              <a:t> 104 </a:t>
+            </a:r>
+            <a:r>
+              <a:rPr lang="zh-TW" altLang="en-US" sz="1050" dirty="0">
+                <a:solidFill>
+                  <a:srgbClr val="667085"/>
+                </a:solidFill>
+                <a:latin typeface="Arial"/>
+                <a:ea typeface="Arial"/>
+                <a:cs typeface="Arial"/>
+              </a:rPr>
+              <a:t>特性</a:t>
+            </a:r>
+            <a:endParaRPr sz="1050" b="0" dirty="0">
+              <a:solidFill>
+                <a:srgbClr val="667085"/>
+              </a:solidFill>
+              <a:latin typeface="Arial"/>
+              <a:ea typeface="Arial"/>
+              <a:cs typeface="Arial"/>
+            </a:endParaRPr>
           </a:p>
         </p:txBody>
       </p:sp>
@@ -27471,7 +27396,87 @@
                 <a:ea typeface="Arial"/>
                 <a:cs typeface="Arial"/>
               </a:rPr>
-              <a:t>driver／ORM；長時間穩定性待驗</a:t>
+              <a:t>driver／ORM</a:t>
+            </a:r>
+            <a:r>
+              <a:rPr sz="1050" b="0" dirty="0">
+                <a:solidFill>
+                  <a:srgbClr val="667085"/>
+                </a:solidFill>
+                <a:latin typeface="Arial"/>
+                <a:ea typeface="Arial"/>
+                <a:cs typeface="Arial"/>
+              </a:rPr>
+              <a:t>；</a:t>
+            </a:r>
+            <a:endParaRPr lang="en-US" sz="1050" b="0" dirty="0">
+              <a:solidFill>
+                <a:srgbClr val="667085"/>
+              </a:solidFill>
+              <a:latin typeface="Arial"/>
+              <a:ea typeface="Arial"/>
+              <a:cs typeface="Arial"/>
+            </a:endParaRPr>
+          </a:p>
+          <a:p>
+            <a:pPr algn="l">
+              <a:lnSpc>
+                <a:spcPct val="105000"/>
+              </a:lnSpc>
+              <a:buNone/>
+              <a:defRPr sz="1050" b="0">
+                <a:solidFill>
+                  <a:srgbClr val="667085"/>
+                </a:solidFill>
+                <a:latin typeface="Arial"/>
+                <a:ea typeface="Arial"/>
+                <a:cs typeface="Arial"/>
+              </a:defRPr>
+            </a:pPr>
+            <a:endParaRPr lang="en-US" sz="1050" dirty="0">
+              <a:solidFill>
+                <a:srgbClr val="667085"/>
+              </a:solidFill>
+              <a:latin typeface="Arial"/>
+              <a:ea typeface="Arial"/>
+              <a:cs typeface="Arial"/>
+            </a:endParaRPr>
+          </a:p>
+          <a:p>
+            <a:pPr>
+              <a:lnSpc>
+                <a:spcPct val="105000"/>
+              </a:lnSpc>
+              <a:defRPr sz="1050" b="0">
+                <a:solidFill>
+                  <a:srgbClr val="667085"/>
+                </a:solidFill>
+                <a:latin typeface="Arial"/>
+                <a:ea typeface="Arial"/>
+                <a:cs typeface="Arial"/>
+              </a:defRPr>
+            </a:pPr>
+            <a:r>
+              <a:rPr lang="en-US" altLang="zh-TW" sz="1050" dirty="0">
+                <a:solidFill>
+                  <a:srgbClr val="667085"/>
+                </a:solidFill>
+                <a:latin typeface="Arial"/>
+                <a:ea typeface="Arial"/>
+                <a:cs typeface="Arial"/>
+              </a:rPr>
+              <a:t>{FIXME} </a:t>
+            </a:r>
+            <a:r>
+              <a:rPr lang="zh-TW" altLang="en-US" sz="1050" b="0" dirty="0">
+                <a:solidFill>
+                  <a:srgbClr val="667085"/>
+                </a:solidFill>
+                <a:latin typeface="Arial"/>
+                <a:ea typeface="Arial"/>
+                <a:cs typeface="Arial"/>
+              </a:rPr>
+              <a:t>補充產品特性</a:t>
             </a:r>
             <a:endParaRPr sz="1050" b="0" dirty="0">
               <a:solidFill>
@@ -27862,7 +27867,7 @@
         </p:nvSpPr>
         <p:spPr>
           <a:xfrm>
-            <a:off x="8686800" y="3590925"/>
+            <a:off x="8686800" y="3646680"/>
             <a:ext cx="2095500" cy="781050"/>
           </a:xfrm>
           <a:prstGeom prst="rect">
@@ -27925,9 +27930,20 @@
                 <a:ea typeface="Arial"/>
                 <a:cs typeface="Arial"/>
               </a:rPr>
-              <a:t>driver／ORM；長時間穩定性待驗</a:t>
-            </a:r>
-            <a:endParaRPr sz="1050" b="0" dirty="0">
+              <a:t>driver／ORM</a:t>
+            </a:r>
+            <a:r>
+              <a:rPr sz="1050" b="0" dirty="0">
+                <a:solidFill>
+                  <a:srgbClr val="667085"/>
+                </a:solidFill>
+                <a:latin typeface="Arial"/>
+                <a:ea typeface="Arial"/>
+                <a:cs typeface="Arial"/>
+              </a:rPr>
+              <a:t>；</a:t>
+            </a:r>
+            <a:endParaRPr lang="en-US" sz="1050" b="0" dirty="0">
               <a:solidFill>
                 <a:srgbClr val="667085"/>
               </a:solidFill>
@@ -27935,6 +27951,67 @@
               <a:ea typeface="Arial"/>
               <a:cs typeface="Arial"/>
             </a:endParaRPr>
+          </a:p>
+          <a:p>
+            <a:pPr algn="l">
+              <a:lnSpc>
+                <a:spcPct val="105000"/>
+              </a:lnSpc>
+              <a:buNone/>
+              <a:defRPr sz="1050" b="0">
+                <a:solidFill>
+                  <a:srgbClr val="667085"/>
+                </a:solidFill>
+                <a:latin typeface="Arial"/>
+                <a:ea typeface="Arial"/>
+                <a:cs typeface="Arial"/>
+              </a:defRPr>
+            </a:pPr>
+            <a:endParaRPr lang="en-US" sz="1050" dirty="0">
+              <a:solidFill>
+                <a:srgbClr val="667085"/>
+              </a:solidFill>
+              <a:latin typeface="Arial"/>
+              <a:ea typeface="Arial"/>
+              <a:cs typeface="Arial"/>
+            </a:endParaRPr>
+          </a:p>
+          <a:p>
+            <a:pPr>
+              <a:lnSpc>
+                <a:spcPct val="105000"/>
+              </a:lnSpc>
+              <a:defRPr sz="1050" b="0">
+                <a:solidFill>
+                  <a:srgbClr val="667085"/>
+                </a:solidFill>
+                <a:latin typeface="Arial"/>
+                <a:ea typeface="Arial"/>
+                <a:cs typeface="Arial"/>
+              </a:defRPr>
+            </a:pPr>
+            <a:r>
+              <a:rPr lang="en-US" altLang="zh-TW" sz="1050" dirty="0">
+                <a:solidFill>
+                  <a:srgbClr val="667085"/>
+                </a:solidFill>
+                <a:latin typeface="Arial"/>
+                <a:ea typeface="Arial"/>
+                <a:cs typeface="Arial"/>
+              </a:rPr>
+              <a:t>{FIXME} </a:t>
+            </a:r>
+            <a:r>
+              <a:rPr lang="zh-TW" altLang="en-US" sz="1050" dirty="0">
+                <a:solidFill>
+                  <a:srgbClr val="667085"/>
+                </a:solidFill>
+                <a:latin typeface="Arial"/>
+                <a:ea typeface="Arial"/>
+                <a:cs typeface="Arial"/>
+              </a:rPr>
+              <a:t>補充產品特性</a:t>
+            </a:r>
           </a:p>
         </p:txBody>
       </p:sp>
@@ -29664,7 +29741,7 @@
               </a:defRPr>
             </a:pPr>
             <a:r>
-              <a:rPr sz="1125" b="0">
+              <a:rPr sz="1125" b="0" dirty="0">
                 <a:solidFill>
                   <a:srgbClr val="101828"/>
                 </a:solidFill>
@@ -30116,17 +30193,14 @@
                 <a:cs typeface="Arial"/>
               </a:defRPr>
             </a:pPr>
-            <a:r>
-              <a:rPr sz="1050" b="1">
-                <a:solidFill>
-                  <a:srgbClr val="2563EB"/>
-                </a:solidFill>
-                <a:latin typeface="Arial"/>
-                <a:ea typeface="Arial"/>
-                <a:cs typeface="Arial"/>
-              </a:rPr>
-              <a:t>A/S 同 workload 對照；兩批次日期不同，僅作 placement 方向判讀。</a:t>
-            </a:r>
+            <a:endParaRPr sz="1050" b="1" dirty="0">
+              <a:solidFill>
+                <a:srgbClr val="2563EB"/>
+              </a:solidFill>
+              <a:latin typeface="Arial"/>
+              <a:ea typeface="Arial"/>
+              <a:cs typeface="Arial"/>
+            </a:endParaRPr>
           </a:p>
         </p:txBody>
       </p:sp>
@@ -33296,8 +33370,7 @@
           </a:bodyPr>
           <a:lstStyle/>
           <a:p>
-            <a:pPr algn="l">
-              <a:buNone/>
+            <a:pPr>
               <a:defRPr sz="3000" b="1">
                 <a:solidFill>
                   <a:srgbClr val="111827"/>
@@ -33308,7 +33381,7 @@
               </a:defRPr>
             </a:pPr>
             <a:r>
-              <a:rPr sz="3000" b="1">
+              <a:rPr lang="en-US" altLang="zh-TW" sz="3000" b="1" dirty="0">
                 <a:solidFill>
                   <a:srgbClr val="111827"/>
                 </a:solidFill>
@@ -33316,7 +33389,7 @@
                 <a:ea typeface="PingFang TC"/>
                 <a:cs typeface="PingFang TC"/>
               </a:rPr>
-              <a:t>主線按風險遞進：S0 → S1 → S2；A/A 延後</a:t>
+              <a:t>What next?</a:t>
             </a:r>
           </a:p>
         </p:txBody>
@@ -33854,7 +33927,7 @@
               </a:defRPr>
             </a:pPr>
             <a:r>
-              <a:rPr sz="1050" b="0">
+              <a:rPr lang="en-US" sz="1050" b="0" dirty="0">
                 <a:solidFill>
                   <a:srgbClr val="101828"/>
                 </a:solidFill>
@@ -33862,8 +33935,80 @@
                 <a:ea typeface="Arial"/>
                 <a:cs typeface="Arial"/>
               </a:rPr>
+              <a:t>- </a:t>
+            </a:r>
+            <a:r>
+              <a:rPr sz="1050" b="0" dirty="0" err="1">
+                <a:solidFill>
+                  <a:srgbClr val="101828"/>
+                </a:solidFill>
+                <a:latin typeface="Arial"/>
+                <a:ea typeface="Arial"/>
+                <a:cs typeface="Arial"/>
+              </a:rPr>
               <a:t>維運／備份／監控</a:t>
             </a:r>
+            <a:endParaRPr sz="1050" b="0" dirty="0">
+              <a:solidFill>
+                <a:srgbClr val="101828"/>
+              </a:solidFill>
+              <a:latin typeface="Arial"/>
+              <a:ea typeface="Arial"/>
+              <a:cs typeface="Arial"/>
+            </a:endParaRPr>
+          </a:p>
+          <a:p>
+            <a:pPr>
+              <a:defRPr sz="1050" b="0">
+                <a:solidFill>
+                  <a:srgbClr val="101828"/>
+                </a:solidFill>
+                <a:latin typeface="Arial"/>
+                <a:ea typeface="Arial"/>
+                <a:cs typeface="Arial"/>
+              </a:defRPr>
+            </a:pPr>
+            <a:r>
+              <a:rPr lang="en" altLang="zh-TW" sz="1050" dirty="0">
+                <a:solidFill>
+                  <a:srgbClr val="101828"/>
+                </a:solidFill>
+                <a:latin typeface="Arial"/>
+                <a:ea typeface="Arial"/>
+                <a:cs typeface="Arial"/>
+              </a:rPr>
+              <a:t>- Pilot </a:t>
+            </a:r>
+            <a:r>
+              <a:rPr sz="1050" b="0" dirty="0" err="1">
+                <a:solidFill>
+                  <a:srgbClr val="101828"/>
+                </a:solidFill>
+                <a:latin typeface="Arial"/>
+                <a:ea typeface="Arial"/>
+                <a:cs typeface="Arial"/>
+              </a:rPr>
+              <a:t>應用</a:t>
+            </a:r>
+            <a:r>
+              <a:rPr lang="en-US" sz="1050" dirty="0">
+                <a:solidFill>
+                  <a:srgbClr val="101828"/>
+                </a:solidFill>
+                <a:latin typeface="Arial"/>
+                <a:ea typeface="Arial"/>
+                <a:cs typeface="Arial"/>
+              </a:rPr>
+              <a:t>: Account Center</a:t>
+            </a:r>
+            <a:endParaRPr sz="1050" b="0" dirty="0">
+              <a:solidFill>
+                <a:srgbClr val="101828"/>
+              </a:solidFill>
+              <a:latin typeface="Arial"/>
+              <a:ea typeface="Arial"/>
+              <a:cs typeface="Arial"/>
+            </a:endParaRPr>
           </a:p>
           <a:p>
             <a:pPr algn="l">
@@ -33881,7 +34026,7 @@
               </a:defRPr>
             </a:pPr>
             <a:r>
-              <a:rPr sz="1050" b="0">
+              <a:rPr lang="en-US" sz="1050" b="0" dirty="0">
                 <a:solidFill>
                   <a:srgbClr val="101828"/>
                 </a:solidFill>
@@ -33889,26 +34034,21 @@
                 <a:ea typeface="Arial"/>
                 <a:cs typeface="Arial"/>
               </a:rPr>
-              <a:t>代表性應用 Pilot</a:t>
-            </a:r>
-          </a:p>
-          <a:p>
-            <a:pPr algn="l">
-              <a:lnSpc>
-                <a:spcPct val="100000"/>
-              </a:lnSpc>
-              <a:buNone/>
-              <a:defRPr sz="1050" b="0">
+              <a:t>- </a:t>
+            </a:r>
+            <a:r>
+              <a:rPr sz="1050" b="0" dirty="0" err="1">
                 <a:solidFill>
                   <a:srgbClr val="101828"/>
                 </a:solidFill>
                 <a:latin typeface="Arial"/>
                 <a:ea typeface="Arial"/>
                 <a:cs typeface="Arial"/>
-              </a:defRPr>
-            </a:pPr>
-            <a:r>
-              <a:rPr sz="1050" b="0">
+              </a:rPr>
+              <a:t>協作</a:t>
+            </a:r>
+            <a:r>
+              <a:rPr sz="1050" b="0" dirty="0">
                 <a:solidFill>
                   <a:srgbClr val="101828"/>
                 </a:solidFill>
@@ -33916,8 +34056,27 @@
                 <a:ea typeface="Arial"/>
                 <a:cs typeface="Arial"/>
               </a:rPr>
-              <a:t>協作：產品 Owner、TSD／RD、DevOps、SRE</a:t>
-            </a:r>
+              <a:t>：</a:t>
+            </a:r>
+            <a:r>
+              <a:rPr lang="zh-TW" altLang="en-US" sz="1050" b="0" dirty="0">
+                <a:solidFill>
+                  <a:srgbClr val="101828"/>
+                </a:solidFill>
+                <a:latin typeface="Arial"/>
+                <a:ea typeface="Arial"/>
+                <a:cs typeface="Arial"/>
+              </a:rPr>
+              <a:t>僅需虛擬化平台資源</a:t>
+            </a:r>
+            <a:endParaRPr sz="1050" b="0" dirty="0">
+              <a:solidFill>
+                <a:srgbClr val="101828"/>
+              </a:solidFill>
+              <a:latin typeface="Arial"/>
+              <a:ea typeface="Arial"/>
+              <a:cs typeface="Arial"/>
+            </a:endParaRPr>
           </a:p>
         </p:txBody>
       </p:sp>
@@ -34130,7 +34289,7 @@
               </a:defRPr>
             </a:pPr>
             <a:r>
-              <a:rPr sz="1050" b="0">
+              <a:rPr lang="en-US" sz="1050" b="0" dirty="0">
                 <a:solidFill>
                   <a:srgbClr val="101828"/>
                 </a:solidFill>
@@ -34138,8 +34297,60 @@
                 <a:ea typeface="Arial"/>
                 <a:cs typeface="Arial"/>
               </a:rPr>
-              <a:t>IDC 主寫／EDC 副本</a:t>
-            </a:r>
+              <a:t>- </a:t>
+            </a:r>
+            <a:r>
+              <a:rPr sz="1050" b="0" dirty="0">
+                <a:solidFill>
+                  <a:srgbClr val="101828"/>
+                </a:solidFill>
+                <a:latin typeface="Arial"/>
+                <a:ea typeface="Arial"/>
+                <a:cs typeface="Arial"/>
+              </a:rPr>
+              <a:t>IDC </a:t>
+            </a:r>
+            <a:r>
+              <a:rPr sz="1050" b="0" dirty="0" err="1">
+                <a:solidFill>
+                  <a:srgbClr val="101828"/>
+                </a:solidFill>
+                <a:latin typeface="Arial"/>
+                <a:ea typeface="Arial"/>
+                <a:cs typeface="Arial"/>
+              </a:rPr>
+              <a:t>主寫／EDC</a:t>
+            </a:r>
+            <a:r>
+              <a:rPr sz="1050" b="0" dirty="0">
+                <a:solidFill>
+                  <a:srgbClr val="101828"/>
+                </a:solidFill>
+                <a:latin typeface="Arial"/>
+                <a:ea typeface="Arial"/>
+                <a:cs typeface="Arial"/>
+              </a:rPr>
+              <a:t> </a:t>
+            </a:r>
+            <a:r>
+              <a:rPr sz="1050" b="0" dirty="0" err="1">
+                <a:solidFill>
+                  <a:srgbClr val="101828"/>
+                </a:solidFill>
+                <a:latin typeface="Arial"/>
+                <a:ea typeface="Arial"/>
+                <a:cs typeface="Arial"/>
+              </a:rPr>
+              <a:t>副本</a:t>
+            </a:r>
+            <a:endParaRPr sz="1050" b="0" dirty="0">
+              <a:solidFill>
+                <a:srgbClr val="101828"/>
+              </a:solidFill>
+              <a:latin typeface="Arial"/>
+              <a:ea typeface="Arial"/>
+              <a:cs typeface="Arial"/>
+            </a:endParaRPr>
           </a:p>
           <a:p>
             <a:pPr algn="l">
@@ -34157,7 +34368,7 @@
               </a:defRPr>
             </a:pPr>
             <a:r>
-              <a:rPr sz="1050" b="0">
+              <a:rPr lang="en-US" sz="1050" b="0" dirty="0">
                 <a:solidFill>
                   <a:srgbClr val="101828"/>
                 </a:solidFill>
@@ -34165,8 +34376,27 @@
                 <a:ea typeface="Arial"/>
                 <a:cs typeface="Arial"/>
               </a:rPr>
+              <a:t>- </a:t>
+            </a:r>
+            <a:r>
+              <a:rPr sz="1050" b="0" dirty="0" err="1">
+                <a:solidFill>
+                  <a:srgbClr val="101828"/>
+                </a:solidFill>
+                <a:latin typeface="Arial"/>
+                <a:ea typeface="Arial"/>
+                <a:cs typeface="Arial"/>
+              </a:rPr>
               <a:t>切換與回復演練</a:t>
             </a:r>
+            <a:endParaRPr sz="1050" b="0" dirty="0">
+              <a:solidFill>
+                <a:srgbClr val="101828"/>
+              </a:solidFill>
+              <a:latin typeface="Arial"/>
+              <a:ea typeface="Arial"/>
+              <a:cs typeface="Arial"/>
+            </a:endParaRPr>
           </a:p>
           <a:p>
             <a:pPr algn="l">
@@ -34184,7 +34414,7 @@
               </a:defRPr>
             </a:pPr>
             <a:r>
-              <a:rPr sz="1050" b="0">
+              <a:rPr lang="en-US" sz="1050" b="0" dirty="0">
                 <a:solidFill>
                   <a:srgbClr val="101828"/>
                 </a:solidFill>
@@ -34192,7 +34422,51 @@
                 <a:ea typeface="Arial"/>
                 <a:cs typeface="Arial"/>
               </a:rPr>
-              <a:t>協作：Infra／Cloud、Network、產品 Owner、SRE</a:t>
+              <a:t>- </a:t>
+            </a:r>
+            <a:r>
+              <a:rPr sz="1050" b="0" dirty="0" err="1">
+                <a:solidFill>
+                  <a:srgbClr val="101828"/>
+                </a:solidFill>
+                <a:latin typeface="Arial"/>
+                <a:ea typeface="Arial"/>
+                <a:cs typeface="Arial"/>
+              </a:rPr>
+              <a:t>協作：</a:t>
+            </a:r>
+            <a:r>
+              <a:rPr lang="en-US" sz="1050" b="0" dirty="0" err="1">
+                <a:solidFill>
+                  <a:srgbClr val="101828"/>
+                </a:solidFill>
+                <a:latin typeface="Arial"/>
+                <a:ea typeface="Arial"/>
+                <a:cs typeface="Arial"/>
+              </a:rPr>
+              <a:t>SE</a:t>
+            </a:r>
+            <a:r>
+              <a:rPr lang="en-US" sz="1050" b="0" dirty="0">
+                <a:solidFill>
+                  <a:srgbClr val="101828"/>
+                </a:solidFill>
+                <a:latin typeface="Arial"/>
+                <a:ea typeface="Arial"/>
+                <a:cs typeface="Arial"/>
+              </a:rPr>
+              <a:t> / HVM / </a:t>
+            </a:r>
+            <a:r>
+              <a:rPr sz="1050" b="0" dirty="0">
+                <a:solidFill>
+                  <a:srgbClr val="101828"/>
+                </a:solidFill>
+                <a:latin typeface="Arial"/>
+                <a:ea typeface="Arial"/>
+                <a:cs typeface="Arial"/>
+              </a:rPr>
+              <a:t>Network</a:t>
             </a:r>
           </a:p>
         </p:txBody>
@@ -34406,7 +34680,7 @@
               </a:defRPr>
             </a:pPr>
             <a:r>
-              <a:rPr sz="1050" b="0">
+              <a:rPr lang="en-US" sz="1050" b="0" dirty="0">
                 <a:solidFill>
                   <a:srgbClr val="101828"/>
                 </a:solidFill>
@@ -34414,8 +34688,38 @@
                 <a:ea typeface="Arial"/>
                 <a:cs typeface="Arial"/>
               </a:rPr>
-              <a:t>EDC 就近讀</a:t>
-            </a:r>
+              <a:t>- </a:t>
+            </a:r>
+            <a:r>
+              <a:rPr sz="1050" b="0" dirty="0">
+                <a:solidFill>
+                  <a:srgbClr val="101828"/>
+                </a:solidFill>
+                <a:latin typeface="Arial"/>
+                <a:ea typeface="Arial"/>
+                <a:cs typeface="Arial"/>
+              </a:rPr>
+              <a:t>EDC </a:t>
+            </a:r>
+            <a:r>
+              <a:rPr sz="1050" b="0" dirty="0" err="1">
+                <a:solidFill>
+                  <a:srgbClr val="101828"/>
+                </a:solidFill>
+                <a:latin typeface="Arial"/>
+                <a:ea typeface="Arial"/>
+                <a:cs typeface="Arial"/>
+              </a:rPr>
+              <a:t>就近讀</a:t>
+            </a:r>
+            <a:endParaRPr sz="1050" b="0" dirty="0">
+              <a:solidFill>
+                <a:srgbClr val="101828"/>
+              </a:solidFill>
+              <a:latin typeface="Arial"/>
+              <a:ea typeface="Arial"/>
+              <a:cs typeface="Arial"/>
+            </a:endParaRPr>
           </a:p>
           <a:p>
             <a:pPr algn="l">
@@ -34433,7 +34737,7 @@
               </a:defRPr>
             </a:pPr>
             <a:r>
-              <a:rPr sz="1050" b="0">
+              <a:rPr lang="en-US" sz="1050" b="0" dirty="0">
                 <a:solidFill>
                   <a:srgbClr val="101828"/>
                 </a:solidFill>
@@ -34441,26 +34745,21 @@
                 <a:ea typeface="Arial"/>
                 <a:cs typeface="Arial"/>
               </a:rPr>
-              <a:t>staleness／fallback</a:t>
-            </a:r>
-          </a:p>
-          <a:p>
-            <a:pPr algn="l">
-              <a:lnSpc>
-                <a:spcPct val="100000"/>
-              </a:lnSpc>
-              <a:buNone/>
-              <a:defRPr sz="1050" b="0">
+              <a:t>- </a:t>
+            </a:r>
+            <a:r>
+              <a:rPr lang="en-US" sz="1050" b="0" dirty="0" err="1">
                 <a:solidFill>
                   <a:srgbClr val="101828"/>
                 </a:solidFill>
                 <a:latin typeface="Arial"/>
                 <a:ea typeface="Arial"/>
                 <a:cs typeface="Arial"/>
-              </a:defRPr>
-            </a:pPr>
-            <a:r>
-              <a:rPr sz="1050" b="0">
+              </a:rPr>
+              <a:t>確認可在</a:t>
+            </a:r>
+            <a:r>
+              <a:rPr lang="en-US" sz="1050" b="0" dirty="0">
                 <a:solidFill>
                   <a:srgbClr val="101828"/>
                 </a:solidFill>
@@ -34468,7 +34767,82 @@
                 <a:ea typeface="Arial"/>
                 <a:cs typeface="Arial"/>
               </a:rPr>
-              <a:t>協作：產品 Owner、TSD／RD、Network／LB、SRE</a:t>
+              <a:t> EDC </a:t>
+            </a:r>
+            <a:r>
+              <a:rPr lang="en-US" sz="1050" b="0" dirty="0" err="1">
+                <a:solidFill>
+                  <a:srgbClr val="101828"/>
+                </a:solidFill>
+                <a:latin typeface="Arial"/>
+                <a:ea typeface="Arial"/>
+                <a:cs typeface="Arial"/>
+              </a:rPr>
+              <a:t>獨立運作的</a:t>
+            </a:r>
+            <a:r>
+              <a:rPr lang="en-US" sz="1050" dirty="0" err="1">
+                <a:solidFill>
+                  <a:srgbClr val="101828"/>
+                </a:solidFill>
+                <a:latin typeface="Arial"/>
+                <a:ea typeface="Arial"/>
+                <a:cs typeface="Arial"/>
+              </a:rPr>
+              <a:t>需求</a:t>
+            </a:r>
+            <a:endParaRPr lang="en-US" sz="1050" b="0" dirty="0">
+              <a:solidFill>
+                <a:srgbClr val="101828"/>
+              </a:solidFill>
+              <a:latin typeface="Arial"/>
+              <a:ea typeface="Arial"/>
+              <a:cs typeface="Arial"/>
+            </a:endParaRPr>
+          </a:p>
+          <a:p>
+            <a:pPr>
+              <a:defRPr sz="1050" b="0">
+                <a:solidFill>
+                  <a:srgbClr val="101828"/>
+                </a:solidFill>
+                <a:latin typeface="Arial"/>
+                <a:ea typeface="Arial"/>
+                <a:cs typeface="Arial"/>
+              </a:defRPr>
+            </a:pPr>
+            <a:r>
+              <a:rPr sz="1050" b="0" dirty="0" err="1">
+                <a:solidFill>
+                  <a:srgbClr val="101828"/>
+                </a:solidFill>
+                <a:latin typeface="Arial"/>
+                <a:ea typeface="Arial"/>
+                <a:cs typeface="Arial"/>
+              </a:rPr>
+              <a:t>協作：TSD／RD</a:t>
+            </a:r>
+            <a:r>
+              <a:rPr lang="en-US" sz="1050" b="0" dirty="0">
+                <a:solidFill>
+                  <a:srgbClr val="101828"/>
+                </a:solidFill>
+                <a:latin typeface="Arial"/>
+                <a:ea typeface="Arial"/>
+                <a:cs typeface="Arial"/>
+              </a:rPr>
+              <a:t> / </a:t>
+            </a:r>
+            <a:r>
+              <a:rPr lang="en-US" altLang="zh-TW" sz="1050" dirty="0">
+                <a:solidFill>
+                  <a:srgbClr val="101828"/>
+                </a:solidFill>
+                <a:latin typeface="Arial"/>
+                <a:ea typeface="Arial"/>
+                <a:cs typeface="Arial"/>
+              </a:rPr>
+              <a:t>SE / HVM / Network</a:t>
             </a:r>
           </a:p>
         </p:txBody>
@@ -34682,7 +35056,7 @@
               </a:defRPr>
             </a:pPr>
             <a:r>
-              <a:rPr sz="1050" b="0">
+              <a:rPr sz="1050" b="0" dirty="0" err="1">
                 <a:solidFill>
                   <a:srgbClr val="101828"/>
                 </a:solidFill>
@@ -34690,8 +35064,38 @@
                 <a:ea typeface="Arial"/>
                 <a:cs typeface="Arial"/>
               </a:rPr>
-              <a:t>雙區寫入需求與 ROI 成立</a:t>
-            </a:r>
+              <a:t>雙區寫入需求與</a:t>
+            </a:r>
+            <a:r>
+              <a:rPr sz="1050" b="0" dirty="0">
+                <a:solidFill>
+                  <a:srgbClr val="101828"/>
+                </a:solidFill>
+                <a:latin typeface="Arial"/>
+                <a:ea typeface="Arial"/>
+                <a:cs typeface="Arial"/>
+              </a:rPr>
+              <a:t> ROI </a:t>
+            </a:r>
+            <a:r>
+              <a:rPr sz="1050" b="0" dirty="0" err="1">
+                <a:solidFill>
+                  <a:srgbClr val="101828"/>
+                </a:solidFill>
+                <a:latin typeface="Arial"/>
+                <a:ea typeface="Arial"/>
+                <a:cs typeface="Arial"/>
+              </a:rPr>
+              <a:t>成立</a:t>
+            </a:r>
+            <a:endParaRPr sz="1050" b="0" dirty="0">
+              <a:solidFill>
+                <a:srgbClr val="101828"/>
+              </a:solidFill>
+              <a:latin typeface="Arial"/>
+              <a:ea typeface="Arial"/>
+              <a:cs typeface="Arial"/>
+            </a:endParaRPr>
           </a:p>
           <a:p>
             <a:pPr algn="l">
@@ -34709,7 +35113,7 @@
               </a:defRPr>
             </a:pPr>
             <a:r>
-              <a:rPr sz="1050" b="0">
+              <a:rPr sz="1050" b="0" dirty="0" err="1">
                 <a:solidFill>
                   <a:srgbClr val="101828"/>
                 </a:solidFill>
@@ -34717,26 +35121,21 @@
                 <a:ea typeface="Arial"/>
                 <a:cs typeface="Arial"/>
               </a:rPr>
-              <a:t>非 DB 阻礙解除後再評估</a:t>
-            </a:r>
-          </a:p>
-          <a:p>
-            <a:pPr algn="l">
-              <a:lnSpc>
-                <a:spcPct val="100000"/>
-              </a:lnSpc>
-              <a:buNone/>
-              <a:defRPr sz="1050" b="0">
+              <a:t>非</a:t>
+            </a:r>
+            <a:r>
+              <a:rPr sz="1050" b="0" dirty="0">
                 <a:solidFill>
                   <a:srgbClr val="101828"/>
                 </a:solidFill>
                 <a:latin typeface="Arial"/>
                 <a:ea typeface="Arial"/>
                 <a:cs typeface="Arial"/>
-              </a:defRPr>
-            </a:pPr>
-            <a:r>
-              <a:rPr sz="1050" b="0">
+              </a:rPr>
+              <a:t> DB </a:t>
+            </a:r>
+            <a:r>
+              <a:rPr sz="1050" b="0" dirty="0" err="1">
                 <a:solidFill>
                   <a:srgbClr val="101828"/>
                 </a:solidFill>
@@ -34744,8 +35143,16 @@
                 <a:ea typeface="Arial"/>
                 <a:cs typeface="Arial"/>
               </a:rPr>
-              <a:t>協作：1／2／3</a:t>
-            </a:r>
+              <a:t>阻礙解除後再評估</a:t>
+            </a:r>
+            <a:endParaRPr sz="1050" b="0" dirty="0">
+              <a:solidFill>
+                <a:srgbClr val="101828"/>
+              </a:solidFill>
+              <a:latin typeface="Arial"/>
+              <a:ea typeface="Arial"/>
+              <a:cs typeface="Arial"/>
+            </a:endParaRPr>
           </a:p>
         </p:txBody>
       </p:sp>
@@ -34817,7 +35224,7 @@
         </p:spPr>
         <p:txBody>
           <a:bodyPr wrap="square" lIns="0" tIns="0" rIns="0" bIns="0" anchor="t">
-            <a:normAutofit fontScale="92500"/>
+            <a:normAutofit/>
           </a:bodyPr>
           <a:lstStyle/>
           <a:p>
@@ -34841,18 +35248,7 @@
                 <a:ea typeface="PingFang TC"/>
                 <a:cs typeface="PingFang TC"/>
               </a:rPr>
-              <a:t>遞進原則：前一階段驗收，是下一階段的進入條件；失敗時能清楚歸因與退場</a:t>
-            </a:r>
-            <a:r>
-              <a:rPr lang="en-US" sz="1575" b="1" dirty="0" err="1">
-                <a:solidFill>
-                  <a:srgbClr val="16803C"/>
-                </a:solidFill>
-                <a:latin typeface="PingFang TC"/>
-                <a:ea typeface="PingFang TC"/>
-                <a:cs typeface="PingFang TC"/>
-              </a:rPr>
-              <a:t>標準</a:t>
+              <a:t>遞進原則：前一階段驗收，是下一階段的進入條件；失敗時能清楚歸因</a:t>
             </a:r>
             <a:r>
               <a:rPr sz="1575" b="1" dirty="0">
@@ -35021,6 +35417,60 @@
               </a:rPr>
               <a:t>來源：SLIDE-BRIEF-2026 §3.1–§3.2</a:t>
             </a:r>
+          </a:p>
+        </p:txBody>
+      </p:sp>
+      <p:sp>
+        <p:nvSpPr>
+          <p:cNvPr id="6" name="文字方塊 5">
+            <a:extLst>
+              <a:ext uri="{FF2B5EF4-FFF2-40B4-BE49-F238E27FC236}">
+                <a16:creationId xmlns:a16="http://schemas.microsoft.com/office/drawing/2014/main" id="{EE5400B7-4EFD-2D40-978A-9574E058DE01}"/>
+              </a:ext>
+            </a:extLst>
+          </p:cNvPr>
+          <p:cNvSpPr txBox="1"/>
+          <p:nvPr/>
+        </p:nvSpPr>
+        <p:spPr>
+          <a:xfrm>
+            <a:off x="762000" y="1485900"/>
+            <a:ext cx="8477250" cy="553998"/>
+          </a:xfrm>
+          <a:prstGeom prst="rect">
+            <a:avLst/>
+          </a:prstGeom>
+          <a:noFill/>
+        </p:spPr>
+        <p:txBody>
+          <a:bodyPr wrap="square">
+            <a:spAutoFit/>
+          </a:bodyPr>
+          <a:lstStyle/>
+          <a:p>
+            <a:r>
+              <a:rPr lang="zh-TW" altLang="en-US" sz="3000" b="1" dirty="0">
+                <a:solidFill>
+                  <a:srgbClr val="111827"/>
+                </a:solidFill>
+                <a:latin typeface="PingFang TC"/>
+                <a:ea typeface="PingFang TC"/>
+                <a:cs typeface="PingFang TC"/>
+              </a:rPr>
+              <a:t>分階段執行</a:t>
+            </a:r>
+            <a:r>
+              <a:rPr lang="en-US" altLang="zh-TW" sz="3000" b="1" dirty="0">
+                <a:solidFill>
+                  <a:srgbClr val="111827"/>
+                </a:solidFill>
+                <a:latin typeface="PingFang TC"/>
+                <a:ea typeface="PingFang TC"/>
+                <a:cs typeface="PingFang TC"/>
+              </a:rPr>
+              <a:t> S0 → S1 → S2</a:t>
+            </a:r>
+            <a:endParaRPr lang="zh-TW" altLang="en-US" dirty="0"/>
           </a:p>
         </p:txBody>
       </p:sp>

</xml_diff>